<commit_message>
Phiên bản 1.1: đồng bộ nội dung phản biện (massage/thuật ngữ, giá tận nhà, vốn 165tr + phép tính, pháp lý NĐ 96/2023, nhân sự), DOCX tái cấu trúc + phụ lục B, HTML thêm sửa chữ (mã 1234321) + ẩn/hiện điều khiển (H/F)
</commit_message>
<xml_diff>
--- a/CareTouch-deck.pptx
+++ b/CareTouch-deck.pptx
@@ -1512,7 +1512,7 @@
           <a:p>
             <a:r>
               <a:rPr lang="en-US" dirty="0"/>
-              <a:t>Doanh thu vượt chi phí cố định 48 triệu từ tháng 5. Tháng 12 đạt 88 triệu với 60% từ gói định kỳ. Mọi số liệu là giả định minh họa, sẽ thay bằng khảo sát địa bàn thực tế.</a:t>
+              <a:t>Tổng vốn khởi đầu 165 triệu = 95 triệu đầu tư + 70 triệu vốn lưu động bù lỗ 4 tháng đầu (26+18+10+4=58 triệu, dự trù dư 12 triệu). Doanh thu vượt chi phí cố định 48 triệu từ tháng 5; lãi ròng lũy kế T5-T12 = 174 triệu ≥ 165 triệu nên hoàn vốn đủ trong khoảng 12 tháng. Kịch bản thận trọng (quay lại 55%): 12-14 tháng. Nhân sự: 4 KTV + nhóm sáng lập điều phối.</a:t>
             </a:r>
             <a:endParaRPr lang="en-US" dirty="0"/>
           </a:p>
@@ -1688,7 +1688,7 @@
           <a:p>
             <a:r>
               <a:rPr lang="en-US" dirty="0"/>
-              <a:t>Hai rủi ro mức cao đều thuộc lĩnh vực pháp lý-an toàn. Chiến lược chung: định vị 'chăm sóc-thư giãn', không xâm phạm phạm vi khám chữa bệnh.</a:t>
+              <a:t>Hai rủi ro mức cao đều thuộc pháp lý - an toàn. Chiến lược: định vị 'chăm sóc - thư giãn - hỗ trợ vận động', không xâm phạm phạm vi khám chữa bệnh theo Luật KBBC 2023 và NĐ 96/2023/NĐ-CP. Nhân sự vận hành: 4 KTV lương cứng + nhóm sáng lập trực tiếp điều phối giai đoạn đầu; năm 2 tuyển thêm điều phối viên toàn thời gian.</a:t>
             </a:r>
             <a:endParaRPr lang="en-US" dirty="0"/>
           </a:p>
@@ -2480,7 +2480,7 @@
           <a:p>
             <a:r>
               <a:rPr lang="en-US" dirty="0"/>
-              <a:t>Điểm khác biệt vận hành quan trọng nhất: sàng lọc y khoa bắt buộc. Đây là thứ spa thư giãn và quán nhỏ không làm.</a:t>
+              <a:t>Điểm khác biệt vận hành quan trọng nhất: khảo sát thể trạng bắt buộc trước mỗi buổi. Đây là thứ spa thư giãn và quán nhỏ không làm.</a:t>
             </a:r>
             <a:endParaRPr lang="en-US" dirty="0"/>
           </a:p>
@@ -3112,7 +3112,7 @@
                 <a:ea typeface="Segoe UI" pitchFamily="34" charset="-122"/>
                 <a:cs typeface="Segoe UI" pitchFamily="34" charset="-120"/>
               </a:rPr>
-              <a:t>Chạm trị liệu y học cổ truyền — gội đầu dưỡng sinh, matxa trị liệu, bấm huyệt, chườm thảo dược. Phục vụ tại cơ sở và tận nhà cho người trung niên và cao tuổi.</a:t>
+              <a:t>Chạm trị liệu y học cổ truyền — gội đầu dưỡng sinh, massage trị liệu, bấm huyệt, chườm thảo dược. Phục vụ tại cơ sở và tận nhà cho người trung niên và cao tuổi.</a:t>
             </a:r>
             <a:endParaRPr lang="en-US" sz="1500" dirty="0"/>
           </a:p>
@@ -3327,7 +3327,7 @@
                 <a:ea typeface="Segoe UI" pitchFamily="34" charset="-122"/>
                 <a:cs typeface="Segoe UI" pitchFamily="34" charset="-120"/>
               </a:rPr>
-              <a:t>Hòa vốn từ tháng thứ 5 — hoàn vốn trong 12–14 tháng vận hành</a:t>
+              <a:t>Hòa vốn vận hành từ tháng thứ 5 — hoàn vốn đầy đủ trong khoảng 12 tháng</a:t>
             </a:r>
             <a:endParaRPr lang="en-US" sz="2700" dirty="0"/>
           </a:p>
@@ -3564,7 +3564,7 @@
               <a:buNone/>
             </a:pPr>
             <a:r>
-              <a:rPr lang="en-US" sz="2100" b="1" dirty="0">
+              <a:rPr lang="en-US" sz="1900" b="1" dirty="0">
                 <a:solidFill>
                   <a:srgbClr val="0E7C6B"/>
                 </a:solidFill>
@@ -3572,9 +3572,9 @@
                 <a:ea typeface="Segoe UI" pitchFamily="34" charset="-122"/>
                 <a:cs typeface="Segoe UI" pitchFamily="34" charset="-120"/>
               </a:rPr>
-              <a:t>95 tr.</a:t>
-            </a:r>
-            <a:endParaRPr lang="en-US" sz="2100" dirty="0"/>
+              <a:t>165 tr.</a:t>
+            </a:r>
+            <a:endParaRPr lang="en-US" sz="1900" dirty="0"/>
           </a:p>
         </ns0:txBody>
       </ns0:sp>
@@ -3614,7 +3614,7 @@
                 <a:ea typeface="Segoe UI" pitchFamily="34" charset="-122"/>
                 <a:cs typeface="Segoe UI" pitchFamily="34" charset="-120"/>
               </a:rPr>
-              <a:t>vốn đầu tư ban đầu (cải tạo, dụng cụ, quảng bá khai trương)</a:t>
+              <a:t>tổng vốn khởi đầu = 95 tr. đầu tư ban đầu + 70 tr. vốn lưu động bù lỗ 4 tháng đầu</a:t>
             </a:r>
             <a:endParaRPr lang="en-US" sz="1050" dirty="0"/>
           </a:p>
@@ -3729,7 +3729,7 @@
                 <a:ea typeface="Segoe UI" pitchFamily="34" charset="-122"/>
                 <a:cs typeface="Segoe UI" pitchFamily="34" charset="-120"/>
               </a:rPr>
-              <a:t>chi phí cố định: thuê 12tr + lương 4 người 32tr + điện nước, vật tư, khấu hao</a:t>
+              <a:t>chi phí cố định: thuê 12tr + lương 4 kỹ thuật viên 32tr + điện nước, vật tư, khấu hao</a:t>
             </a:r>
             <a:endParaRPr lang="en-US" sz="1050" dirty="0"/>
           </a:p>
@@ -3973,6 +3973,95 @@
         </ns0:nvSpPr>
         <ns0:spPr>
           <a:xfrm>
+            <a:off x="795528" y="5669280"/>
+            <a:ext cx="6035040" cy="274320"/>
+          </a:xfrm>
+          <a:prstGeom prst="rect">
+            <a:avLst/>
+          </a:prstGeom>
+          <a:noFill/>
+          <a:ln/>
+        </ns0:spPr>
+        <ns0:txBody>
+          <a:bodyPr wrap="square" lIns="0" tIns="0" rIns="0" bIns="0" rtlCol="0" anchor="ctr"/>
+          <a:lstStyle/>
+          <a:p>
+            <a:pPr indent="0" marL="0">
+              <a:buNone/>
+            </a:pPr>
+            <a:r>
+              <a:rPr lang="en-US" sz="1050" i="1" dirty="0">
+                <a:solidFill>
+                  <a:srgbClr val="5C7370"/>
+                </a:solidFill>
+                <a:latin typeface="Segoe UI" pitchFamily="34" charset="0"/>
+                <a:ea typeface="Segoe UI" pitchFamily="34" charset="-122"/>
+                <a:cs typeface="Segoe UI" pitchFamily="34" charset="-120"/>
+              </a:rPr>
+              <a:t>T4: 44 &lt; 48 &lt; T5: 50  →  </a:t>
+            </a:r>
+            <a:r>
+              <a:rPr lang="en-US" sz="1050" b="1" i="1" dirty="0">
+                <a:solidFill>
+                  <a:srgbClr val="E8590C"/>
+                </a:solidFill>
+                <a:latin typeface="Segoe UI" pitchFamily="34" charset="0"/>
+                <a:ea typeface="Segoe UI" pitchFamily="34" charset="-122"/>
+                <a:cs typeface="Segoe UI" pitchFamily="34" charset="-120"/>
+              </a:rPr>
+              <a:t>hòa vốn ngay tháng thứ 5</a:t>
+            </a:r>
+            <a:endParaRPr lang="en-US" sz="1050" dirty="0"/>
+          </a:p>
+        </ns0:txBody>
+      </ns0:sp>
+      <ns0:sp>
+        <ns0:nvSpPr>
+          <ns0:cNvPr id="23" name="Text 20"/>
+          <ns0:cNvSpPr/>
+          <ns0:nvPr/>
+        </ns0:nvSpPr>
+        <ns0:spPr>
+          <a:xfrm>
+            <a:off x="502920" y="6163056"/>
+            <a:ext cx="11155680" cy="274320"/>
+          </a:xfrm>
+          <a:prstGeom prst="rect">
+            <a:avLst/>
+          </a:prstGeom>
+          <a:noFill/>
+          <a:ln/>
+        </ns0:spPr>
+        <ns0:txBody>
+          <a:bodyPr wrap="square" lIns="0" tIns="0" rIns="0" bIns="0" rtlCol="0" anchor="ctr"/>
+          <a:lstStyle/>
+          <a:p>
+            <a:pPr indent="0" marL="0">
+              <a:buNone/>
+            </a:pPr>
+            <a:r>
+              <a:rPr lang="en-US" sz="1050" i="1" dirty="0">
+                <a:solidFill>
+                  <a:srgbClr val="5C7370"/>
+                </a:solidFill>
+                <a:latin typeface="Segoe UI" pitchFamily="34" charset="0"/>
+                <a:ea typeface="Segoe UI" pitchFamily="34" charset="-122"/>
+                <a:cs typeface="Segoe UI" pitchFamily="34" charset="-120"/>
+              </a:rPr>
+              <a:t>Phép tính: lỗ lũy kế T1–T4 = 26 + 18 + 10 + 4 = 58 triệu → dự trù vốn lưu động 70 triệu; lãi ròng lũy kế T5–T12 = 174 triệu ≥ 165 triệu → hoàn vốn đủ trong ~12 tháng.</a:t>
+            </a:r>
+            <a:endParaRPr lang="en-US" sz="1050" dirty="0"/>
+          </a:p>
+        </ns0:txBody>
+      </ns0:sp>
+      <ns0:sp>
+        <ns0:nvSpPr>
+          <ns0:cNvPr id="24" name="Text 21"/>
+          <ns0:cNvSpPr/>
+          <ns0:nvPr/>
+        </ns0:nvSpPr>
+        <ns0:spPr>
+          <a:xfrm>
             <a:off x="502920" y="6473952"/>
             <a:ext cx="11155680" cy="274320"/>
           </a:xfrm>
@@ -3998,7 +4087,7 @@
                 <a:ea typeface="Segoe UI" pitchFamily="34" charset="-122"/>
                 <a:cs typeface="Segoe UI" pitchFamily="34" charset="-120"/>
               </a:rPr>
-              <a:t>Giả định minh họa theo mô hình vận hành của nhóm: 1 cơ sở 2 giường trị liệu + 3 kỹ thuật viên phục vụ tại nhà; giá theo bảng giá đề xuất (slide 6).</a:t>
+              <a:t>Giả định minh họa của nhóm: 1 cơ sở 2 giường trị liệu; 4 kỹ thuật viên (lương cứng ~8 tr. + phụ cấp ca tại nhà), nhóm sáng lập trực tiếp điều phối; giá theo bảng giá đề xuất (slide 6).</a:t>
             </a:r>
             <a:endParaRPr lang="en-US" sz="1050" dirty="0"/>
           </a:p>
@@ -5158,7 +5247,7 @@
                 <a:ea typeface="Segoe UI" pitchFamily="34" charset="-122"/>
                 <a:cs typeface="Segoe UI" pitchFamily="34" charset="-120"/>
               </a:rPr>
-              <a:t>Nhìn thẳng rủi ro — và cách hóa giải từng cái</a:t>
+              <a:t>Nhìn thẳng rủi ro — và giải pháp ứng phó cho từng cái</a:t>
             </a:r>
             <a:endParaRPr lang="en-US" sz="2700" dirty="0"/>
           </a:p>
@@ -5413,7 +5502,7 @@
                 <a:ea typeface="Segoe UI" pitchFamily="34" charset="-122"/>
                 <a:cs typeface="Segoe UI" pitchFamily="34" charset="-120"/>
               </a:rPr>
-              <a:t>Hóa giải:  </a:t>
+              <a:t>Giải pháp:  </a:t>
             </a:r>
             <a:r>
               <a:rPr lang="en-US" sz="1080" dirty="0">
@@ -5424,7 +5513,7 @@
                 <a:ea typeface="Segoe UI" pitchFamily="34" charset="-122"/>
                 <a:cs typeface="Segoe UI" pitchFamily="34" charset="-120"/>
               </a:rPr>
-              <a:t>Định vị dịch vụ chăm sóc – thư giãn – phục hồi vận động; không khám bệnh, không kê thuốc, không quảng cáo chữa bệnh; bác sĩ y học cổ truyền cộng tác phụ trách chuyên môn; kỹ thuật viên thi chứng chỉ nghề.</a:t>
+              <a:t>Định vị chăm sóc – thư giãn – hỗ trợ vận động; không khám bệnh, không kê thuốc, không thực hiện kỹ thuật thuộc phạm vi khám chữa bệnh (Luật Khám bệnh, chữa bệnh 2023; Nghị định 96/2023/NĐ-CP); bác sĩ y học cổ truyền cộng tác; kỹ thuật viên thi chứng chỉ nghề.</a:t>
             </a:r>
             <a:endParaRPr lang="en-US" sz="1080" dirty="0"/>
           </a:p>
@@ -5596,7 +5685,7 @@
                 <a:ea typeface="Segoe UI" pitchFamily="34" charset="-122"/>
                 <a:cs typeface="Segoe UI" pitchFamily="34" charset="-120"/>
               </a:rPr>
-              <a:t>Hóa giải:  </a:t>
+              <a:t>Giải pháp:  </a:t>
             </a:r>
             <a:r>
               <a:rPr lang="en-US" sz="1080" dirty="0">
@@ -5607,7 +5696,7 @@
                 <a:ea typeface="Segoe UI" pitchFamily="34" charset="-122"/>
                 <a:cs typeface="Segoe UI" pitchFamily="34" charset="-120"/>
               </a:rPr>
-              <a:t>Sàng lọc bắt buộc buổi đầu (hỏi bệnh nền, đo huyết áp); từ chối hoặc khuyên đi khám khi có chống chỉ định; mua bảo hiểm trách nhiệm dịch vụ.</a:t>
+              <a:t>Khảo sát bắt buộc buổi đầu (hỏi bệnh nền, đo huyết áp); từ chối hoặc khuyên đi khám khi có chống chỉ định; mua bảo hiểm trách nhiệm dịch vụ.</a:t>
             </a:r>
             <a:endParaRPr lang="en-US" sz="1080" dirty="0"/>
           </a:p>
@@ -5779,7 +5868,7 @@
                 <a:ea typeface="Segoe UI" pitchFamily="34" charset="-122"/>
                 <a:cs typeface="Segoe UI" pitchFamily="34" charset="-120"/>
               </a:rPr>
-              <a:t>Hóa giải:  </a:t>
+              <a:t>Giải pháp:  </a:t>
             </a:r>
             <a:r>
               <a:rPr lang="en-US" sz="1080" dirty="0">
@@ -5962,7 +6051,7 @@
                 <a:ea typeface="Segoe UI" pitchFamily="34" charset="-122"/>
                 <a:cs typeface="Segoe UI" pitchFamily="34" charset="-120"/>
               </a:rPr>
-              <a:t>Hóa giải:  </a:t>
+              <a:t>Giải pháp:  </a:t>
             </a:r>
             <a:r>
               <a:rPr lang="en-US" sz="1080" dirty="0">
@@ -6012,7 +6101,7 @@
                 <a:ea typeface="Segoe UI" pitchFamily="34" charset="-122"/>
                 <a:cs typeface="Segoe UI" pitchFamily="34" charset="-120"/>
               </a:rPr>
-              <a:t>Đánh giá mức độ rủi ro của nhóm dựa trên quy định hiện hành về massage – trị liệu phục hồi chức năng và khảo sát thực địa.</a:t>
+              <a:t>Đánh giá rủi ro của nhóm dựa trên quy định hiện hành về massage – xoa bóp (Luật Khám bệnh, chữa bệnh 2023; Nghị định 96/2023/NĐ-CP) và khảo sát thực địa.</a:t>
             </a:r>
             <a:endParaRPr lang="en-US" sz="1050" dirty="0"/>
           </a:p>
@@ -10200,7 +10289,7 @@
                 <a:ea typeface="Segoe UI" pitchFamily="34" charset="-122"/>
                 <a:cs typeface="Segoe UI" pitchFamily="34" charset="-120"/>
               </a:rPr>
-              <a:t>thu nhập bình quân đầu người 2025 đạt 5,9 triệu đồng/tháng (+9,3% so với 2024) — mức giá 120.000–290.000 đ/phiên nằm trong tầm chi trả định kỳ của nhóm mục tiêu.  </a:t>
+              <a:t>thu nhập bình quân đầu người 2025 đạt 5,9 triệu đồng/tháng (+9,3% so với 2024) — mức giá 120.000–320.000 đ/phiên nằm trong tầm chi trả định kỳ của nhóm mục tiêu.  </a:t>
             </a:r>
             <a:r>
               <a:rPr lang="en-US" sz="1100" u="sng" dirty="0">
@@ -10767,7 +10856,7 @@
                 <a:ea typeface="Segoe UI" pitchFamily="34" charset="-122"/>
                 <a:cs typeface="Segoe UI" pitchFamily="34" charset="-120"/>
               </a:rPr>
-              <a:t>Home care rời rạc</a:t>
+              <a:t>Tại nhà tự phát</a:t>
             </a:r>
             <a:endParaRPr lang="en-US" sz="1050" dirty="0"/>
           </a:p>
@@ -11112,7 +11201,7 @@
                 <a:ea typeface="Segoe UI" pitchFamily="34" charset="-122"/>
                 <a:cs typeface="Segoe UI" pitchFamily="34" charset="-120"/>
               </a:rPr>
-              <a:t>An toàn có sàng lọc</a:t>
+              <a:t>Khảo sát thể trạng trước buổi trị liệu</a:t>
             </a:r>
             <a:endParaRPr lang="en-US" sz="1450" dirty="0"/>
           </a:p>
@@ -12184,7 +12273,7 @@
                           <a:ea typeface="Segoe UI" pitchFamily="34" charset="-122"/>
                           <a:cs typeface="Segoe UI" pitchFamily="34" charset="-120"/>
                         </a:rPr>
-                        <a:t>180.000</a:t>
+                        <a:t>200.000</a:t>
                       </a:r>
                       <a:endParaRPr lang="en-US" sz="1300" dirty="0">
                         <a:latin typeface="Segoe UI" charset="0"/>
@@ -12254,7 +12343,7 @@
                           <a:ea typeface="Segoe UI" pitchFamily="34" charset="-122"/>
                           <a:cs typeface="Segoe UI" pitchFamily="34" charset="-120"/>
                         </a:rPr>
-                        <a:t>Matxa cổ – vai – gáy trị liệu</a:t>
+                        <a:t>Massage cổ – vai – gáy trị liệu</a:t>
                       </a:r>
                       <a:endParaRPr lang="en-US" sz="1300" dirty="0">
                         <a:latin typeface="Segoe UI" charset="0"/>
@@ -12458,7 +12547,7 @@
                           <a:ea typeface="Segoe UI" pitchFamily="34" charset="-122"/>
                           <a:cs typeface="Segoe UI" pitchFamily="34" charset="-120"/>
                         </a:rPr>
-                        <a:t>250.000</a:t>
+                        <a:t>270.000</a:t>
                       </a:r>
                       <a:endParaRPr lang="en-US" sz="1300" dirty="0">
                         <a:latin typeface="Segoe UI" charset="0"/>
@@ -12528,7 +12617,7 @@
                           <a:ea typeface="Segoe UI" pitchFamily="34" charset="-122"/>
                           <a:cs typeface="Segoe UI" pitchFamily="34" charset="-120"/>
                         </a:rPr>
-                        <a:t>Matxa toàn thân thư giãn</a:t>
+                        <a:t>Massage toàn thân thư giãn</a:t>
                       </a:r>
                       <a:endParaRPr lang="en-US" sz="1300" dirty="0">
                         <a:latin typeface="Segoe UI" charset="0"/>
@@ -12732,7 +12821,7 @@
                           <a:ea typeface="Segoe UI" pitchFamily="34" charset="-122"/>
                           <a:cs typeface="Segoe UI" pitchFamily="34" charset="-120"/>
                         </a:rPr>
-                        <a:t>290.000</a:t>
+                        <a:t>320.000</a:t>
                       </a:r>
                       <a:endParaRPr lang="en-US" sz="1300" dirty="0">
                         <a:latin typeface="Segoe UI" charset="0"/>
@@ -13006,7 +13095,7 @@
                           <a:ea typeface="Segoe UI" pitchFamily="34" charset="-122"/>
                           <a:cs typeface="Segoe UI" pitchFamily="34" charset="-120"/>
                         </a:rPr>
-                        <a:t>270.000</a:t>
+                        <a:t>290.000</a:t>
                       </a:r>
                       <a:endParaRPr lang="en-US" sz="1300" dirty="0">
                         <a:latin typeface="Segoe UI" charset="0"/>
@@ -13471,7 +13560,7 @@
                 <a:ea typeface="Segoe UI" pitchFamily="34" charset="-122"/>
                 <a:cs typeface="Segoe UI" pitchFamily="34" charset="-120"/>
               </a:rPr>
-              <a:t>Xa hơn: phụ thu 20.000 đ mỗi 5 km. Kỹ thuật viên mang theo đầy đủ đệm, dầu xoa, khăn sạch.</a:t>
+              <a:t>Xa hơn: phụ thu 20.000 đ mỗi 5 km; khách đặt tối thiểu 2 buổi mỗi lượt. Kỹ thuật viên mang theo đầy đủ đệm, dầu xoa, khăn sạch.</a:t>
             </a:r>
             <a:endParaRPr lang="en-US" sz="1500" dirty="0"/>
           </a:p>
@@ -13573,7 +13662,7 @@
                 <a:ea typeface="Segoe UI" pitchFamily="34" charset="-122"/>
                 <a:cs typeface="Segoe UI" pitchFamily="34" charset="-120"/>
               </a:rPr>
-              <a:t>Thị trường tại nhà cho người lớn tuổi: 350.000–620.000 đ/phiên (TP.HCM). CareTouch đặt ngay dưới phân khúc spa — vừa túi tiền, vẫn chuyên nghiệp.</a:t>
+              <a:t>Thị trường tại nhà cho người lớn tuổi: 350.000–620.000 đ/phiên (TP.HCM). CareTouch ở khoảng 200.000–320.000 đ — chênh lệch 80–100 nghìn đ bù thời gian di chuyển, vẫn dưới phân khúc spa.</a:t>
             </a:r>
             <a:endParaRPr lang="en-US" sz="1400" dirty="0"/>
           </a:p>
@@ -13922,7 +14011,7 @@
         <ns0:spPr>
           <a:xfrm>
             <a:off x="777240" y="2395728"/>
-            <a:ext cx="3108960" cy="685800"/>
+            <a:ext cx="3154680" cy="685800"/>
           </a:xfrm>
           <a:prstGeom prst="rect">
             <a:avLst/>
@@ -13938,7 +14027,7 @@
               <a:buNone/>
             </a:pPr>
             <a:r>
-              <a:rPr lang="en-US" sz="3800" b="1" dirty="0">
+              <a:rPr lang="en-US" sz="2100" b="1" dirty="0">
                 <a:solidFill>
                   <a:srgbClr val="16302B"/>
                 </a:solidFill>
@@ -13946,20 +14035,9 @@
                 <a:ea typeface="Segoe UI" pitchFamily="34" charset="-122"/>
                 <a:cs typeface="Segoe UI" pitchFamily="34" charset="-120"/>
               </a:rPr>
-              <a:t>120–290K</a:t>
-            </a:r>
-            <a:r>
-              <a:rPr lang="en-US" sz="1250" dirty="0">
-                <a:solidFill>
-                  <a:srgbClr val="5C7370"/>
-                </a:solidFill>
-                <a:latin typeface="Segoe UI" pitchFamily="34" charset="0"/>
-                <a:ea typeface="Segoe UI" pitchFamily="34" charset="-122"/>
-                <a:cs typeface="Segoe UI" pitchFamily="34" charset="-120"/>
-              </a:rPr>
-              <a:t>  đ/phiên</a:t>
-            </a:r>
-            <a:endParaRPr lang="en-US" sz="3800" dirty="0"/>
+              <a:t>120.000–290.000 đ</a:t>
+            </a:r>
+            <a:endParaRPr lang="en-US" sz="2100" dirty="0"/>
           </a:p>
         </ns0:txBody>
       </ns0:sp>
@@ -14139,7 +14217,7 @@
         <ns0:spPr>
           <a:xfrm>
             <a:off x="4553712" y="2395728"/>
-            <a:ext cx="3108960" cy="685800"/>
+            <a:ext cx="3154680" cy="685800"/>
           </a:xfrm>
           <a:prstGeom prst="rect">
             <a:avLst/>
@@ -14155,7 +14233,7 @@
               <a:buNone/>
             </a:pPr>
             <a:r>
-              <a:rPr lang="en-US" sz="3800" b="1" dirty="0">
+              <a:rPr lang="en-US" sz="3400" b="1" dirty="0">
                 <a:solidFill>
                   <a:srgbClr val="0E7C6B"/>
                 </a:solidFill>
@@ -14163,10 +14241,10 @@
                 <a:ea typeface="Segoe UI" pitchFamily="34" charset="-122"/>
                 <a:cs typeface="Segoe UI" pitchFamily="34" charset="-120"/>
               </a:rPr>
-              <a:t>890K</a:t>
-            </a:r>
-            <a:r>
-              <a:rPr lang="en-US" sz="1250" dirty="0">
+              <a:t>890.000 đ</a:t>
+            </a:r>
+            <a:r>
+              <a:rPr lang="en-US" sz="1200" dirty="0">
                 <a:solidFill>
                   <a:srgbClr val="5C7370"/>
                 </a:solidFill>
@@ -14176,7 +14254,7 @@
               </a:rPr>
               <a:t>  tiết kiệm ~15%</a:t>
             </a:r>
-            <a:endParaRPr lang="en-US" sz="3800" dirty="0"/>
+            <a:endParaRPr lang="en-US" sz="3400" dirty="0"/>
           </a:p>
         </ns0:txBody>
       </ns0:sp>
@@ -14220,7 +14298,7 @@
                 <a:ea typeface="Segoe UI" pitchFamily="34" charset="-122"/>
                 <a:cs typeface="Segoe UI" pitchFamily="34" charset="-120"/>
               </a:rPr>
-              <a:t>Mix 3 dịch vụ tùy ý</a:t>
+              <a:t>Tự chọn kết hợp 3 dịch vụ</a:t>
             </a:r>
             <a:endParaRPr lang="en-US" sz="1200" dirty="0"/>
           </a:p>
@@ -14356,7 +14434,7 @@
         <ns0:spPr>
           <a:xfrm>
             <a:off x="8330184" y="2395728"/>
-            <a:ext cx="3108960" cy="685800"/>
+            <a:ext cx="3154680" cy="685800"/>
           </a:xfrm>
           <a:prstGeom prst="rect">
             <a:avLst/>
@@ -14372,7 +14450,7 @@
               <a:buNone/>
             </a:pPr>
             <a:r>
-              <a:rPr lang="en-US" sz="3800" b="1" dirty="0">
+              <a:rPr lang="en-US" sz="3100" b="1" dirty="0">
                 <a:solidFill>
                   <a:srgbClr val="F7965A"/>
                 </a:solidFill>
@@ -14380,10 +14458,10 @@
                 <a:ea typeface="Segoe UI" pitchFamily="34" charset="-122"/>
                 <a:cs typeface="Segoe UI" pitchFamily="34" charset="-120"/>
               </a:rPr>
-              <a:t>1.590K</a:t>
-            </a:r>
-            <a:r>
-              <a:rPr lang="en-US" sz="1250" dirty="0">
+              <a:t>1.590.000 đ</a:t>
+            </a:r>
+            <a:r>
+              <a:rPr lang="en-US" sz="1200" dirty="0">
                 <a:solidFill>
                   <a:srgbClr val="B9D8D0"/>
                 </a:solidFill>
@@ -14391,9 +14469,9 @@
                 <a:ea typeface="Segoe UI" pitchFamily="34" charset="-122"/>
                 <a:cs typeface="Segoe UI" pitchFamily="34" charset="-120"/>
               </a:rPr>
-              <a:t>  tiết kiệm ~20%</a:t>
-            </a:r>
-            <a:endParaRPr lang="en-US" sz="3800" dirty="0"/>
+              <a:t>  ~20%</a:t>
+            </a:r>
+            <a:endParaRPr lang="en-US" sz="3100" dirty="0"/>
           </a:p>
         </ns0:txBody>
       </ns0:sp>
@@ -14871,7 +14949,7 @@
                 <a:ea typeface="Segoe UI" pitchFamily="34" charset="-122"/>
                 <a:cs typeface="Segoe UI" pitchFamily="34" charset="-120"/>
               </a:rPr>
-              <a:t>Sàng lọc</a:t>
+              <a:t>Khảo sát</a:t>
             </a:r>
             <a:endParaRPr lang="en-US" sz="1700" dirty="0"/>
           </a:p>
@@ -15615,7 +15693,7 @@
                 <a:ea typeface="Segoe UI" pitchFamily="34" charset="-122"/>
                 <a:cs typeface="Segoe UI" pitchFamily="34" charset="-120"/>
               </a:rPr>
-              <a:t>Khoảng trống thị trường: professional care cho trung niên – cao tuổi còn bỏ ngỏ</a:t>
+              <a:t>Khoảng trống thị trường: dịch vụ chăm sóc chuyên nghiệp cho trung niên – cao tuổi còn bỏ ngỏ</a:t>
             </a:r>
             <a:endParaRPr lang="en-US" sz="2700" dirty="0"/>
           </a:p>
@@ -16023,7 +16101,7 @@
                           <a:ea typeface="Segoe UI" pitchFamily="34" charset="-122"/>
                           <a:cs typeface="Segoe UI" pitchFamily="34" charset="-120"/>
                         </a:rPr>
-                        <a:t>Home care rời rạc</a:t>
+                        <a:t>Tại nhà tự phát</a:t>
                       </a:r>
                       <a:endParaRPr lang="en-US" sz="1250" dirty="0">
                         <a:latin typeface="Segoe UI" charset="0"/>
@@ -16777,7 +16855,7 @@
                           <a:ea typeface="Segoe UI" pitchFamily="34" charset="-122"/>
                           <a:cs typeface="Segoe UI" pitchFamily="34" charset="-120"/>
                         </a:rPr>
-                        <a:t>Sàng lọc y khoa trước mỗi buổi</a:t>
+                        <a:t>Khảo sát thể trạng an toàn trước mỗi buổi</a:t>
                       </a:r>
                       <a:endParaRPr lang="en-US" sz="1200" dirty="0">
                         <a:latin typeface="Segoe UI" charset="0"/>
@@ -17803,7 +17881,7 @@
                           <a:ea typeface="Segoe UI" pitchFamily="34" charset="-122"/>
                           <a:cs typeface="Segoe UI" pitchFamily="34" charset="-120"/>
                         </a:rPr>
-                        <a:t>Giá phù hợp chi trả định kỳ (120–290K)</a:t>
+                        <a:t>Giá phù hợp chi trả định kỳ (120–320 nghìn đồng)</a:t>
                       </a:r>
                       <a:endParaRPr lang="en-US" sz="1200" dirty="0">
                         <a:latin typeface="Segoe UI" charset="0"/>

</xml_diff>

<commit_message>
Đồng bộ HTML <-> PPTX (rà soát text + ảnh 14 cặp): PPTX bỏ 'Matxa'/'sàng lọc', thêm dòng đối tượng khách S7 + dòng nhân sự S13 + kịch bản thận trọng S10; HTML thêm 'thị trường' S3, gso.gov.vn S4, '1 cơ sở 2 giường' S10, 'mua bảo hiểm' S12, giá trị tĩnh counter S2, legend HTML slide 10
</commit_message>
<xml_diff>
--- a/CareTouch-deck.pptx
+++ b/CareTouch-deck.pptx
@@ -4048,7 +4048,7 @@
                 <a:ea typeface="Segoe UI" pitchFamily="34" charset="-122"/>
                 <a:cs typeface="Segoe UI" pitchFamily="34" charset="-120"/>
               </a:rPr>
-              <a:t>Phép tính: lỗ lũy kế T1–T4 = 26 + 18 + 10 + 4 = 58 triệu → dự trù vốn lưu động 70 triệu; lãi ròng lũy kế T5–T12 = 174 triệu ≥ 165 triệu → hoàn vốn đủ trong ~12 tháng.</a:t>
+              <a:t>Phép tính: lỗ lũy kế T1–T4 = 26 + 18 + 10 + 4 = 58 triệu → dự trù vốn lưu động 70 triệu; lãi ròng lũy kế T5–T12 = 174 triệu ≥ 165 triệu → hoàn vốn đủ trong ~12 tháng (thận trọng 55%: 12–14 tháng).</a:t>
             </a:r>
             <a:endParaRPr lang="en-US" sz="1050" dirty="0"/>
           </a:p>
@@ -4494,7 +4494,7 @@
                 <a:ea typeface="Segoe UI" pitchFamily="34" charset="-122"/>
                 <a:cs typeface="Segoe UI" pitchFamily="34" charset="-120"/>
               </a:rPr>
-              <a:t>Vận hành cơ sở đầu tiên; chuẩn hóa quy trình sàng lọc &amp; đào tạo; đo tỷ lệ khách quay lại từ tháng đầu.</a:t>
+              <a:t>Vận hành cơ sở đầu tiên; chuẩn hóa quy trình khảo sát thể trạng &amp; đào tạo; đo tỷ lệ khách quay lại từ tháng đầu.</a:t>
             </a:r>
             <a:endParaRPr lang="en-US" sz="1150" dirty="0"/>
           </a:p>
@@ -7234,9 +7234,48 @@
                 <a:ea typeface="Segoe UI" pitchFamily="34" charset="-122"/>
                 <a:cs typeface="Segoe UI" pitchFamily="34" charset="-120"/>
               </a:rPr>
-              <a:t>kỹ thuật viên thi chứng chỉ nghề · bác sĩ y học cổ truyền cộng tác · bảo hiểm trách nhiệm dịch vụ · quy trình sàng lọc an toàn cho mọi buổi trị liệu.</a:t>
+              <a:t>kỹ thuật viên thi chứng chỉ nghề · bác sĩ y học cổ truyền cộng tác · bảo hiểm trách nhiệm dịch vụ · quy trình khảo sát thể trạng an toàn cho mọi buổi trị liệu.</a:t>
             </a:r>
             <a:endParaRPr lang="en-US" sz="1350" dirty="0"/>
+          </a:p>
+        </ns0:txBody>
+      </ns0:sp>
+      <ns0:sp>
+        <ns0:nvSpPr>
+          <ns0:cNvPr id="34" name="Text 32"/>
+          <ns0:cNvSpPr/>
+          <ns0:nvPr/>
+        </ns0:nvSpPr>
+        <ns0:spPr>
+          <a:xfrm>
+            <a:off x="502920" y="6272784"/>
+            <a:ext cx="11183112" cy="274320"/>
+          </a:xfrm>
+          <a:prstGeom prst="rect">
+            <a:avLst/>
+          </a:prstGeom>
+          <a:noFill/>
+          <a:ln/>
+        </ns0:spPr>
+        <ns0:txBody>
+          <a:bodyPr wrap="square" lIns="0" tIns="0" rIns="0" bIns="0" rtlCol="0" anchor="ctr"/>
+          <a:lstStyle/>
+          <a:p>
+            <a:pPr indent="0" marL="0">
+              <a:buNone/>
+            </a:pPr>
+            <a:r>
+              <a:rPr lang="en-US" sz="1100" i="1" dirty="0">
+                <a:solidFill>
+                  <a:srgbClr val="5C7370"/>
+                </a:solidFill>
+                <a:latin typeface="Segoe UI" pitchFamily="34" charset="0"/>
+                <a:ea typeface="Segoe UI" pitchFamily="34" charset="-122"/>
+                <a:cs typeface="Segoe UI" pitchFamily="34" charset="-120"/>
+              </a:rPr>
+              <a:t>Giai đoạn đầu, 5 thành viên sáng lập trực tiếp điều phối lịch, marketing và chăm sóc khách; năm 2 tuyển thêm điều phối viên toàn thời gian.</a:t>
+            </a:r>
+            <a:endParaRPr lang="en-US" sz="1100" dirty="0"/>
           </a:p>
         </ns0:txBody>
       </ns0:sp>
@@ -14133,6 +14172,30 @@
             </a:r>
             <a:endParaRPr lang="en-US" sz="1200" dirty="0"/>
           </a:p>
+          <a:p>
+            <a:pPr marL="152400" indent="-152400">
+              <a:lnSpc>
+                <a:spcPct val="112000"/>
+              </a:lnSpc>
+              <a:spcAft>
+                <a:spcPts val="800"/>
+              </a:spcAft>
+              <a:buSzPct val="100000"/>
+              <a:buChar char="▸"/>
+            </a:pPr>
+            <a:r>
+              <a:rPr lang="en-US" sz="1200" dirty="0">
+                <a:solidFill>
+                  <a:srgbClr val="5C7370"/>
+                </a:solidFill>
+                <a:latin typeface="Segoe UI" pitchFamily="34" charset="0"/>
+                <a:ea typeface="Segoe UI" pitchFamily="34" charset="-122"/>
+                <a:cs typeface="Segoe UI" pitchFamily="34" charset="-120"/>
+              </a:rPr>
+              <a:t>Dành cho khách trải nghiệm lần đầu</a:t>
+            </a:r>
+            <a:endParaRPr lang="en-US" sz="1200" dirty="0"/>
+          </a:p>
         </ns0:txBody>
       </ns0:sp>
       <ns0:sp>
@@ -14350,6 +14413,30 @@
             </a:r>
             <a:endParaRPr lang="en-US" sz="1200" dirty="0"/>
           </a:p>
+          <a:p>
+            <a:pPr marL="152400" indent="-152400">
+              <a:lnSpc>
+                <a:spcPct val="112000"/>
+              </a:lnSpc>
+              <a:spcAft>
+                <a:spcPts val="800"/>
+              </a:spcAft>
+              <a:buSzPct val="100000"/>
+              <a:buChar char="▸"/>
+            </a:pPr>
+            <a:r>
+              <a:rPr lang="en-US" sz="1200" dirty="0">
+                <a:solidFill>
+                  <a:srgbClr val="5C7370"/>
+                </a:solidFill>
+                <a:latin typeface="Segoe UI" pitchFamily="34" charset="0"/>
+                <a:ea typeface="Segoe UI" pitchFamily="34" charset="-122"/>
+                <a:cs typeface="Segoe UI" pitchFamily="34" charset="-120"/>
+              </a:rPr>
+              <a:t>Dành cho liệu trình ngắn 2–4 tuần</a:t>
+            </a:r>
+            <a:endParaRPr lang="en-US" sz="1200" dirty="0"/>
+          </a:p>
         </ns0:txBody>
       </ns0:sp>
       <ns0:sp>
@@ -14564,6 +14651,30 @@
                 <a:cs typeface="Segoe UI" pitchFamily="34" charset="-120"/>
               </a:rPr>
               <a:t>Cho người thân dùng chung</a:t>
+            </a:r>
+            <a:endParaRPr lang="en-US" sz="1200" dirty="0"/>
+          </a:p>
+          <a:p>
+            <a:pPr marL="152400" indent="-152400">
+              <a:lnSpc>
+                <a:spcPct val="112000"/>
+              </a:lnSpc>
+              <a:spcAft>
+                <a:spcPts val="800"/>
+              </a:spcAft>
+              <a:buSzPct val="100000"/>
+              <a:buChar char="▸"/>
+            </a:pPr>
+            <a:r>
+              <a:rPr lang="en-US" sz="1200" dirty="0">
+                <a:solidFill>
+                  <a:srgbClr val="D5EAE4"/>
+                </a:solidFill>
+                <a:latin typeface="Segoe UI" pitchFamily="34" charset="0"/>
+                <a:ea typeface="Segoe UI" pitchFamily="34" charset="-122"/>
+                <a:cs typeface="Segoe UI" pitchFamily="34" charset="-120"/>
+              </a:rPr>
+              <a:t>Gói chủ lực — liệu trình chuẩn &amp; gia đình</a:t>
             </a:r>
             <a:endParaRPr lang="en-US" sz="1200" dirty="0"/>
           </a:p>
@@ -15339,7 +15450,7 @@
                 <a:ea typeface="Segoe UI" pitchFamily="34" charset="-122"/>
                 <a:cs typeface="Segoe UI" pitchFamily="34" charset="-120"/>
               </a:rPr>
-              <a:t>Matxa – bấm huyệt – chườm thảo dược theo bài chuẩn 45–70 phút.</a:t>
+              <a:t>Massage – bấm huyệt – chườm thảo dược theo bài chuẩn 45–70 phút.</a:t>
             </a:r>
             <a:endParaRPr lang="en-US" sz="1150" dirty="0"/>
           </a:p>

</xml_diff>

<commit_message>
Biểu đồ tài chính slide 10: thêm nhãn '48 tr./tháng' ngay trên đường chi phí cố định (PPTX: text shape vị trí đo từ render; HTML: plugin vẽ canvas) — đồng bộ cả hai
</commit_message>
<xml_diff>
--- a/CareTouch-deck.pptx
+++ b/CareTouch-deck.pptx
@@ -4509,6 +4509,45 @@
           </a:p>
         </ns0:txBody>
       </ns0:sp>
+      <ns0:sp>
+        <ns0:nvSpPr>
+          <ns0:cNvPr id="26" name="Text 22"/>
+          <ns0:cNvSpPr/>
+          <ns0:nvPr/>
+        </ns0:nvSpPr>
+        <ns0:spPr>
+          <a:xfrm>
+            <a:off x="1188720" y="3465576"/>
+            <a:ext cx="1143000" cy="182880"/>
+          </a:xfrm>
+          <a:prstGeom prst="rect">
+            <a:avLst/>
+          </a:prstGeom>
+          <a:noFill/>
+          <a:ln/>
+        </ns0:spPr>
+        <ns0:txBody>
+          <a:bodyPr wrap="square" lIns="0" tIns="0" rIns="0" bIns="0" rtlCol="0" anchor="ctr"/>
+          <a:lstStyle/>
+          <a:p>
+            <a:pPr indent="0" marL="0">
+              <a:buNone/>
+            </a:pPr>
+            <a:r>
+              <a:rPr lang="en-US" sz="1000" dirty="0">
+                <a:solidFill>
+                  <a:srgbClr val="16302B"/>
+                </a:solidFill>
+                <a:latin typeface="Segoe UI" pitchFamily="34" charset="0"/>
+                <a:ea typeface="Segoe UI" pitchFamily="34" charset="-122"/>
+                <a:cs typeface="Segoe UI" pitchFamily="34" charset="-120"/>
+              </a:rPr>
+              <a:t>48 tr./tháng</a:t>
+            </a:r>
+            <a:endParaRPr lang="en-US" sz="1000" dirty="0"/>
+          </a:p>
+        </ns0:txBody>
+      </ns0:sp>
     </ns0:spTree>
   </ns0:cSld>
   <ns0:clrMapOvr>
@@ -4532,7 +4571,7 @@
         <ns0:cTn id="1" dur="indefinite" restart="never" nodeType="tmRoot">
           <ns0:childTnLst>
             <ns0:seq concurrent="1" nextAc="seek">
-              <ns0:cTn id="72" dur="indefinite" nodeType="mainSeq">
+              <ns0:cTn id="76" dur="indefinite" nodeType="mainSeq">
                 <ns0:childTnLst>
                   <ns0:par>
                     <ns0:cTn id="2" fill="hold">
@@ -4720,39 +4759,21 @@
                                   </ns0:childTnLst>
                                 </ns0:cTn>
                               </ns0:par>
-                            </ns0:childTnLst>
-                          </ns0:cTn>
-                        </ns0:par>
-                      </ns0:childTnLst>
-                    </ns0:cTn>
-                  </ns0:par>
-                  <ns0:par>
-                    <ns0:cTn id="16" fill="hold">
-                      <ns0:stCondLst>
-                        <ns0:cond delay="indefinite"/>
-                      </ns0:stCondLst>
-                      <ns0:childTnLst>
-                        <ns0:par>
-                          <ns0:cTn id="17" fill="hold">
-                            <ns0:stCondLst>
-                              <ns0:cond delay="0"/>
-                            </ns0:stCondLst>
-                            <ns0:childTnLst>
                               <ns0:par>
-                                <ns0:cTn id="18" presetID="42" presetClass="entr" presetSubtype="0" fill="hold" grpId="0" nodeType="clickEffect">
+                                <ns0:cTn id="16" presetID="42" presetClass="entr" presetSubtype="0" fill="hold" grpId="0" nodeType="withEffect">
                                   <ns0:stCondLst>
-                                    <ns0:cond delay="0"/>
+                                    <ns0:cond delay="300"/>
                                   </ns0:stCondLst>
                                   <ns0:childTnLst>
                                     <ns0:set>
                                       <ns0:cBhvr>
-                                        <ns0:cTn id="19" dur="1" fill="hold">
+                                        <ns0:cTn id="17" dur="1" fill="hold">
                                           <ns0:stCondLst>
                                             <ns0:cond delay="0"/>
                                           </ns0:stCondLst>
                                         </ns0:cTn>
                                         <ns0:tgtEl>
-                                          <ns0:spTgt spid="22"/>
+                                          <ns0:spTgt spid="25"/>
                                         </ns0:tgtEl>
                                         <ns0:attrNameLst>
                                           <ns0:attrName>style.visibility</ns0:attrName>
@@ -4764,17 +4785,17 @@
                                     </ns0:set>
                                     <ns0:animEffect transition="in" filter="fade">
                                       <ns0:cBhvr>
-                                        <ns0:cTn id="20" dur="500"/>
-                                        <ns0:tgtEl>
-                                          <ns0:spTgt spid="22"/>
+                                        <ns0:cTn id="18" dur="500"/>
+                                        <ns0:tgtEl>
+                                          <ns0:spTgt spid="25"/>
                                         </ns0:tgtEl>
                                       </ns0:cBhvr>
                                     </ns0:animEffect>
                                     <ns0:anim calcmode="lin" valueType="num">
                                       <ns0:cBhvr additive="base">
-                                        <ns0:cTn id="21" dur="500" fill="hold"/>
-                                        <ns0:tgtEl>
-                                          <ns0:spTgt spid="22"/>
+                                        <ns0:cTn id="19" dur="500" fill="hold"/>
+                                        <ns0:tgtEl>
+                                          <ns0:spTgt spid="25"/>
                                         </ns0:tgtEl>
                                         <ns0:attrNameLst>
                                           <ns0:attrName>ppt_y</ns0:attrName>
@@ -4803,32 +4824,32 @@
                     </ns0:cTn>
                   </ns0:par>
                   <ns0:par>
-                    <ns0:cTn id="22" fill="hold">
+                    <ns0:cTn id="20" fill="hold">
                       <ns0:stCondLst>
                         <ns0:cond delay="indefinite"/>
                       </ns0:stCondLst>
                       <ns0:childTnLst>
                         <ns0:par>
-                          <ns0:cTn id="23" fill="hold">
+                          <ns0:cTn id="21" fill="hold">
                             <ns0:stCondLst>
                               <ns0:cond delay="0"/>
                             </ns0:stCondLst>
                             <ns0:childTnLst>
                               <ns0:par>
-                                <ns0:cTn id="24" presetID="42" presetClass="entr" presetSubtype="0" fill="hold" grpId="0" nodeType="clickEffect">
+                                <ns0:cTn id="22" presetID="42" presetClass="entr" presetSubtype="0" fill="hold" grpId="0" nodeType="clickEffect">
                                   <ns0:stCondLst>
                                     <ns0:cond delay="0"/>
                                   </ns0:stCondLst>
                                   <ns0:childTnLst>
                                     <ns0:set>
                                       <ns0:cBhvr>
-                                        <ns0:cTn id="25" dur="1" fill="hold">
+                                        <ns0:cTn id="23" dur="1" fill="hold">
                                           <ns0:stCondLst>
                                             <ns0:cond delay="0"/>
                                           </ns0:stCondLst>
                                         </ns0:cTn>
                                         <ns0:tgtEl>
-                                          <ns0:spTgt spid="10"/>
+                                          <ns0:spTgt spid="22"/>
                                         </ns0:tgtEl>
                                         <ns0:attrNameLst>
                                           <ns0:attrName>style.visibility</ns0:attrName>
@@ -4840,17 +4861,17 @@
                                     </ns0:set>
                                     <ns0:animEffect transition="in" filter="fade">
                                       <ns0:cBhvr>
-                                        <ns0:cTn id="26" dur="500"/>
-                                        <ns0:tgtEl>
-                                          <ns0:spTgt spid="10"/>
+                                        <ns0:cTn id="24" dur="500"/>
+                                        <ns0:tgtEl>
+                                          <ns0:spTgt spid="22"/>
                                         </ns0:tgtEl>
                                       </ns0:cBhvr>
                                     </ns0:animEffect>
                                     <ns0:anim calcmode="lin" valueType="num">
                                       <ns0:cBhvr additive="base">
-                                        <ns0:cTn id="27" dur="500" fill="hold"/>
-                                        <ns0:tgtEl>
-                                          <ns0:spTgt spid="10"/>
+                                        <ns0:cTn id="25" dur="500" fill="hold"/>
+                                        <ns0:tgtEl>
+                                          <ns0:spTgt spid="22"/>
                                         </ns0:tgtEl>
                                         <ns0:attrNameLst>
                                           <ns0:attrName>ppt_y</ns0:attrName>
@@ -4872,10 +4893,28 @@
                                   </ns0:childTnLst>
                                 </ns0:cTn>
                               </ns0:par>
+                            </ns0:childTnLst>
+                          </ns0:cTn>
+                        </ns0:par>
+                      </ns0:childTnLst>
+                    </ns0:cTn>
+                  </ns0:par>
+                  <ns0:par>
+                    <ns0:cTn id="26" fill="hold">
+                      <ns0:stCondLst>
+                        <ns0:cond delay="indefinite"/>
+                      </ns0:stCondLst>
+                      <ns0:childTnLst>
+                        <ns0:par>
+                          <ns0:cTn id="27" fill="hold">
+                            <ns0:stCondLst>
+                              <ns0:cond delay="0"/>
+                            </ns0:stCondLst>
+                            <ns0:childTnLst>
                               <ns0:par>
-                                <ns0:cTn id="28" presetID="42" presetClass="entr" presetSubtype="0" fill="hold" grpId="0" nodeType="withEffect">
+                                <ns0:cTn id="28" presetID="42" presetClass="entr" presetSubtype="0" fill="hold" grpId="0" nodeType="clickEffect">
                                   <ns0:stCondLst>
-                                    <ns0:cond delay="80"/>
+                                    <ns0:cond delay="0"/>
                                   </ns0:stCondLst>
                                   <ns0:childTnLst>
                                     <ns0:set>
@@ -4886,7 +4925,7 @@
                                           </ns0:stCondLst>
                                         </ns0:cTn>
                                         <ns0:tgtEl>
-                                          <ns0:spTgt spid="11"/>
+                                          <ns0:spTgt spid="10"/>
                                         </ns0:tgtEl>
                                         <ns0:attrNameLst>
                                           <ns0:attrName>style.visibility</ns0:attrName>
@@ -4900,7 +4939,7 @@
                                       <ns0:cBhvr>
                                         <ns0:cTn id="30" dur="500"/>
                                         <ns0:tgtEl>
-                                          <ns0:spTgt spid="11"/>
+                                          <ns0:spTgt spid="10"/>
                                         </ns0:tgtEl>
                                       </ns0:cBhvr>
                                     </ns0:animEffect>
@@ -4908,7 +4947,7 @@
                                       <ns0:cBhvr additive="base">
                                         <ns0:cTn id="31" dur="500" fill="hold"/>
                                         <ns0:tgtEl>
-                                          <ns0:spTgt spid="11"/>
+                                          <ns0:spTgt spid="10"/>
                                         </ns0:tgtEl>
                                         <ns0:attrNameLst>
                                           <ns0:attrName>ppt_y</ns0:attrName>
@@ -4933,7 +4972,7 @@
                               <ns0:par>
                                 <ns0:cTn id="32" presetID="42" presetClass="entr" presetSubtype="0" fill="hold" grpId="0" nodeType="withEffect">
                                   <ns0:stCondLst>
-                                    <ns0:cond delay="160"/>
+                                    <ns0:cond delay="80"/>
                                   </ns0:stCondLst>
                                   <ns0:childTnLst>
                                     <ns0:set>
@@ -4944,7 +4983,7 @@
                                           </ns0:stCondLst>
                                         </ns0:cTn>
                                         <ns0:tgtEl>
-                                          <ns0:spTgt spid="12"/>
+                                          <ns0:spTgt spid="11"/>
                                         </ns0:tgtEl>
                                         <ns0:attrNameLst>
                                           <ns0:attrName>style.visibility</ns0:attrName>
@@ -4958,7 +4997,7 @@
                                       <ns0:cBhvr>
                                         <ns0:cTn id="34" dur="500"/>
                                         <ns0:tgtEl>
-                                          <ns0:spTgt spid="12"/>
+                                          <ns0:spTgt spid="11"/>
                                         </ns0:tgtEl>
                                       </ns0:cBhvr>
                                     </ns0:animEffect>
@@ -4966,7 +5005,7 @@
                                       <ns0:cBhvr additive="base">
                                         <ns0:cTn id="35" dur="500" fill="hold"/>
                                         <ns0:tgtEl>
-                                          <ns0:spTgt spid="12"/>
+                                          <ns0:spTgt spid="11"/>
                                         </ns0:tgtEl>
                                         <ns0:attrNameLst>
                                           <ns0:attrName>ppt_y</ns0:attrName>
@@ -4991,7 +5030,7 @@
                               <ns0:par>
                                 <ns0:cTn id="36" presetID="42" presetClass="entr" presetSubtype="0" fill="hold" grpId="0" nodeType="withEffect">
                                   <ns0:stCondLst>
-                                    <ns0:cond delay="240"/>
+                                    <ns0:cond delay="160"/>
                                   </ns0:stCondLst>
                                   <ns0:childTnLst>
                                     <ns0:set>
@@ -5002,7 +5041,7 @@
                                           </ns0:stCondLst>
                                         </ns0:cTn>
                                         <ns0:tgtEl>
-                                          <ns0:spTgt spid="13"/>
+                                          <ns0:spTgt spid="12"/>
                                         </ns0:tgtEl>
                                         <ns0:attrNameLst>
                                           <ns0:attrName>style.visibility</ns0:attrName>
@@ -5016,7 +5055,7 @@
                                       <ns0:cBhvr>
                                         <ns0:cTn id="38" dur="500"/>
                                         <ns0:tgtEl>
-                                          <ns0:spTgt spid="13"/>
+                                          <ns0:spTgt spid="12"/>
                                         </ns0:tgtEl>
                                       </ns0:cBhvr>
                                     </ns0:animEffect>
@@ -5024,7 +5063,7 @@
                                       <ns0:cBhvr additive="base">
                                         <ns0:cTn id="39" dur="500" fill="hold"/>
                                         <ns0:tgtEl>
-                                          <ns0:spTgt spid="13"/>
+                                          <ns0:spTgt spid="12"/>
                                         </ns0:tgtEl>
                                         <ns0:attrNameLst>
                                           <ns0:attrName>ppt_y</ns0:attrName>
@@ -5049,7 +5088,7 @@
                               <ns0:par>
                                 <ns0:cTn id="40" presetID="42" presetClass="entr" presetSubtype="0" fill="hold" grpId="0" nodeType="withEffect">
                                   <ns0:stCondLst>
-                                    <ns0:cond delay="320"/>
+                                    <ns0:cond delay="240"/>
                                   </ns0:stCondLst>
                                   <ns0:childTnLst>
                                     <ns0:set>
@@ -5060,7 +5099,7 @@
                                           </ns0:stCondLst>
                                         </ns0:cTn>
                                         <ns0:tgtEl>
-                                          <ns0:spTgt spid="14"/>
+                                          <ns0:spTgt spid="13"/>
                                         </ns0:tgtEl>
                                         <ns0:attrNameLst>
                                           <ns0:attrName>style.visibility</ns0:attrName>
@@ -5074,7 +5113,7 @@
                                       <ns0:cBhvr>
                                         <ns0:cTn id="42" dur="500"/>
                                         <ns0:tgtEl>
-                                          <ns0:spTgt spid="14"/>
+                                          <ns0:spTgt spid="13"/>
                                         </ns0:tgtEl>
                                       </ns0:cBhvr>
                                     </ns0:animEffect>
@@ -5082,7 +5121,7 @@
                                       <ns0:cBhvr additive="base">
                                         <ns0:cTn id="43" dur="500" fill="hold"/>
                                         <ns0:tgtEl>
-                                          <ns0:spTgt spid="14"/>
+                                          <ns0:spTgt spid="13"/>
                                         </ns0:tgtEl>
                                         <ns0:attrNameLst>
                                           <ns0:attrName>ppt_y</ns0:attrName>
@@ -5107,7 +5146,7 @@
                               <ns0:par>
                                 <ns0:cTn id="44" presetID="42" presetClass="entr" presetSubtype="0" fill="hold" grpId="0" nodeType="withEffect">
                                   <ns0:stCondLst>
-                                    <ns0:cond delay="400"/>
+                                    <ns0:cond delay="320"/>
                                   </ns0:stCondLst>
                                   <ns0:childTnLst>
                                     <ns0:set>
@@ -5118,7 +5157,7 @@
                                           </ns0:stCondLst>
                                         </ns0:cTn>
                                         <ns0:tgtEl>
-                                          <ns0:spTgt spid="15"/>
+                                          <ns0:spTgt spid="14"/>
                                         </ns0:tgtEl>
                                         <ns0:attrNameLst>
                                           <ns0:attrName>style.visibility</ns0:attrName>
@@ -5132,7 +5171,7 @@
                                       <ns0:cBhvr>
                                         <ns0:cTn id="46" dur="500"/>
                                         <ns0:tgtEl>
-                                          <ns0:spTgt spid="15"/>
+                                          <ns0:spTgt spid="14"/>
                                         </ns0:tgtEl>
                                       </ns0:cBhvr>
                                     </ns0:animEffect>
@@ -5140,7 +5179,7 @@
                                       <ns0:cBhvr additive="base">
                                         <ns0:cTn id="47" dur="500" fill="hold"/>
                                         <ns0:tgtEl>
-                                          <ns0:spTgt spid="15"/>
+                                          <ns0:spTgt spid="14"/>
                                         </ns0:tgtEl>
                                         <ns0:attrNameLst>
                                           <ns0:attrName>ppt_y</ns0:attrName>
@@ -5165,7 +5204,7 @@
                               <ns0:par>
                                 <ns0:cTn id="48" presetID="42" presetClass="entr" presetSubtype="0" fill="hold" grpId="0" nodeType="withEffect">
                                   <ns0:stCondLst>
-                                    <ns0:cond delay="480"/>
+                                    <ns0:cond delay="400"/>
                                   </ns0:stCondLst>
                                   <ns0:childTnLst>
                                     <ns0:set>
@@ -5176,7 +5215,7 @@
                                           </ns0:stCondLst>
                                         </ns0:cTn>
                                         <ns0:tgtEl>
-                                          <ns0:spTgt spid="16"/>
+                                          <ns0:spTgt spid="15"/>
                                         </ns0:tgtEl>
                                         <ns0:attrNameLst>
                                           <ns0:attrName>style.visibility</ns0:attrName>
@@ -5190,7 +5229,7 @@
                                       <ns0:cBhvr>
                                         <ns0:cTn id="50" dur="500"/>
                                         <ns0:tgtEl>
-                                          <ns0:spTgt spid="16"/>
+                                          <ns0:spTgt spid="15"/>
                                         </ns0:tgtEl>
                                       </ns0:cBhvr>
                                     </ns0:animEffect>
@@ -5198,7 +5237,7 @@
                                       <ns0:cBhvr additive="base">
                                         <ns0:cTn id="51" dur="500" fill="hold"/>
                                         <ns0:tgtEl>
-                                          <ns0:spTgt spid="16"/>
+                                          <ns0:spTgt spid="15"/>
                                         </ns0:tgtEl>
                                         <ns0:attrNameLst>
                                           <ns0:attrName>ppt_y</ns0:attrName>
@@ -5223,7 +5262,7 @@
                               <ns0:par>
                                 <ns0:cTn id="52" presetID="42" presetClass="entr" presetSubtype="0" fill="hold" grpId="0" nodeType="withEffect">
                                   <ns0:stCondLst>
-                                    <ns0:cond delay="560"/>
+                                    <ns0:cond delay="480"/>
                                   </ns0:stCondLst>
                                   <ns0:childTnLst>
                                     <ns0:set>
@@ -5234,7 +5273,7 @@
                                           </ns0:stCondLst>
                                         </ns0:cTn>
                                         <ns0:tgtEl>
-                                          <ns0:spTgt spid="17"/>
+                                          <ns0:spTgt spid="16"/>
                                         </ns0:tgtEl>
                                         <ns0:attrNameLst>
                                           <ns0:attrName>style.visibility</ns0:attrName>
@@ -5248,7 +5287,7 @@
                                       <ns0:cBhvr>
                                         <ns0:cTn id="54" dur="500"/>
                                         <ns0:tgtEl>
-                                          <ns0:spTgt spid="17"/>
+                                          <ns0:spTgt spid="16"/>
                                         </ns0:tgtEl>
                                       </ns0:cBhvr>
                                     </ns0:animEffect>
@@ -5256,7 +5295,7 @@
                                       <ns0:cBhvr additive="base">
                                         <ns0:cTn id="55" dur="500" fill="hold"/>
                                         <ns0:tgtEl>
-                                          <ns0:spTgt spid="17"/>
+                                          <ns0:spTgt spid="16"/>
                                         </ns0:tgtEl>
                                         <ns0:attrNameLst>
                                           <ns0:attrName>ppt_y</ns0:attrName>
@@ -5281,7 +5320,7 @@
                               <ns0:par>
                                 <ns0:cTn id="56" presetID="42" presetClass="entr" presetSubtype="0" fill="hold" grpId="0" nodeType="withEffect">
                                   <ns0:stCondLst>
-                                    <ns0:cond delay="640"/>
+                                    <ns0:cond delay="560"/>
                                   </ns0:stCondLst>
                                   <ns0:childTnLst>
                                     <ns0:set>
@@ -5292,7 +5331,7 @@
                                           </ns0:stCondLst>
                                         </ns0:cTn>
                                         <ns0:tgtEl>
-                                          <ns0:spTgt spid="18"/>
+                                          <ns0:spTgt spid="17"/>
                                         </ns0:tgtEl>
                                         <ns0:attrNameLst>
                                           <ns0:attrName>style.visibility</ns0:attrName>
@@ -5306,7 +5345,7 @@
                                       <ns0:cBhvr>
                                         <ns0:cTn id="58" dur="500"/>
                                         <ns0:tgtEl>
-                                          <ns0:spTgt spid="18"/>
+                                          <ns0:spTgt spid="17"/>
                                         </ns0:tgtEl>
                                       </ns0:cBhvr>
                                     </ns0:animEffect>
@@ -5314,7 +5353,7 @@
                                       <ns0:cBhvr additive="base">
                                         <ns0:cTn id="59" dur="500" fill="hold"/>
                                         <ns0:tgtEl>
-                                          <ns0:spTgt spid="18"/>
+                                          <ns0:spTgt spid="17"/>
                                         </ns0:tgtEl>
                                         <ns0:attrNameLst>
                                           <ns0:attrName>ppt_y</ns0:attrName>
@@ -5339,7 +5378,7 @@
                               <ns0:par>
                                 <ns0:cTn id="60" presetID="42" presetClass="entr" presetSubtype="0" fill="hold" grpId="0" nodeType="withEffect">
                                   <ns0:stCondLst>
-                                    <ns0:cond delay="720"/>
+                                    <ns0:cond delay="640"/>
                                   </ns0:stCondLst>
                                   <ns0:childTnLst>
                                     <ns0:set>
@@ -5350,7 +5389,7 @@
                                           </ns0:stCondLst>
                                         </ns0:cTn>
                                         <ns0:tgtEl>
-                                          <ns0:spTgt spid="19"/>
+                                          <ns0:spTgt spid="18"/>
                                         </ns0:tgtEl>
                                         <ns0:attrNameLst>
                                           <ns0:attrName>style.visibility</ns0:attrName>
@@ -5364,7 +5403,7 @@
                                       <ns0:cBhvr>
                                         <ns0:cTn id="62" dur="500"/>
                                         <ns0:tgtEl>
-                                          <ns0:spTgt spid="19"/>
+                                          <ns0:spTgt spid="18"/>
                                         </ns0:tgtEl>
                                       </ns0:cBhvr>
                                     </ns0:animEffect>
@@ -5372,7 +5411,7 @@
                                       <ns0:cBhvr additive="base">
                                         <ns0:cTn id="63" dur="500" fill="hold"/>
                                         <ns0:tgtEl>
-                                          <ns0:spTgt spid="19"/>
+                                          <ns0:spTgt spid="18"/>
                                         </ns0:tgtEl>
                                         <ns0:attrNameLst>
                                           <ns0:attrName>ppt_y</ns0:attrName>
@@ -5397,7 +5436,7 @@
                               <ns0:par>
                                 <ns0:cTn id="64" presetID="42" presetClass="entr" presetSubtype="0" fill="hold" grpId="0" nodeType="withEffect">
                                   <ns0:stCondLst>
-                                    <ns0:cond delay="800"/>
+                                    <ns0:cond delay="720"/>
                                   </ns0:stCondLst>
                                   <ns0:childTnLst>
                                     <ns0:set>
@@ -5408,7 +5447,7 @@
                                           </ns0:stCondLst>
                                         </ns0:cTn>
                                         <ns0:tgtEl>
-                                          <ns0:spTgt spid="20"/>
+                                          <ns0:spTgt spid="19"/>
                                         </ns0:tgtEl>
                                         <ns0:attrNameLst>
                                           <ns0:attrName>style.visibility</ns0:attrName>
@@ -5422,7 +5461,7 @@
                                       <ns0:cBhvr>
                                         <ns0:cTn id="66" dur="500"/>
                                         <ns0:tgtEl>
-                                          <ns0:spTgt spid="20"/>
+                                          <ns0:spTgt spid="19"/>
                                         </ns0:tgtEl>
                                       </ns0:cBhvr>
                                     </ns0:animEffect>
@@ -5430,7 +5469,7 @@
                                       <ns0:cBhvr additive="base">
                                         <ns0:cTn id="67" dur="500" fill="hold"/>
                                         <ns0:tgtEl>
-                                          <ns0:spTgt spid="20"/>
+                                          <ns0:spTgt spid="19"/>
                                         </ns0:tgtEl>
                                         <ns0:attrNameLst>
                                           <ns0:attrName>ppt_y</ns0:attrName>
@@ -5455,7 +5494,7 @@
                               <ns0:par>
                                 <ns0:cTn id="68" presetID="42" presetClass="entr" presetSubtype="0" fill="hold" grpId="0" nodeType="withEffect">
                                   <ns0:stCondLst>
-                                    <ns0:cond delay="880"/>
+                                    <ns0:cond delay="800"/>
                                   </ns0:stCondLst>
                                   <ns0:childTnLst>
                                     <ns0:set>
@@ -5466,7 +5505,7 @@
                                           </ns0:stCondLst>
                                         </ns0:cTn>
                                         <ns0:tgtEl>
-                                          <ns0:spTgt spid="21"/>
+                                          <ns0:spTgt spid="20"/>
                                         </ns0:tgtEl>
                                         <ns0:attrNameLst>
                                           <ns0:attrName>style.visibility</ns0:attrName>
@@ -5480,13 +5519,71 @@
                                       <ns0:cBhvr>
                                         <ns0:cTn id="70" dur="500"/>
                                         <ns0:tgtEl>
-                                          <ns0:spTgt spid="21"/>
+                                          <ns0:spTgt spid="20"/>
                                         </ns0:tgtEl>
                                       </ns0:cBhvr>
                                     </ns0:animEffect>
                                     <ns0:anim calcmode="lin" valueType="num">
                                       <ns0:cBhvr additive="base">
                                         <ns0:cTn id="71" dur="500" fill="hold"/>
+                                        <ns0:tgtEl>
+                                          <ns0:spTgt spid="20"/>
+                                        </ns0:tgtEl>
+                                        <ns0:attrNameLst>
+                                          <ns0:attrName>ppt_y</ns0:attrName>
+                                        </ns0:attrNameLst>
+                                      </ns0:cBhvr>
+                                      <ns0:tavLst>
+                                        <ns0:tav tm="0">
+                                          <ns0:val>
+                                            <ns0:strVal val="#ppt_y+0.018"/>
+                                          </ns0:val>
+                                        </ns0:tav>
+                                        <ns0:tav tm="100000">
+                                          <ns0:val>
+                                            <ns0:strVal val="#ppt_y"/>
+                                          </ns0:val>
+                                        </ns0:tav>
+                                      </ns0:tavLst>
+                                    </ns0:anim>
+                                  </ns0:childTnLst>
+                                </ns0:cTn>
+                              </ns0:par>
+                              <ns0:par>
+                                <ns0:cTn id="72" presetID="42" presetClass="entr" presetSubtype="0" fill="hold" grpId="0" nodeType="withEffect">
+                                  <ns0:stCondLst>
+                                    <ns0:cond delay="880"/>
+                                  </ns0:stCondLst>
+                                  <ns0:childTnLst>
+                                    <ns0:set>
+                                      <ns0:cBhvr>
+                                        <ns0:cTn id="73" dur="1" fill="hold">
+                                          <ns0:stCondLst>
+                                            <ns0:cond delay="0"/>
+                                          </ns0:stCondLst>
+                                        </ns0:cTn>
+                                        <ns0:tgtEl>
+                                          <ns0:spTgt spid="21"/>
+                                        </ns0:tgtEl>
+                                        <ns0:attrNameLst>
+                                          <ns0:attrName>style.visibility</ns0:attrName>
+                                        </ns0:attrNameLst>
+                                      </ns0:cBhvr>
+                                      <ns0:to>
+                                        <ns0:strVal val="visible"/>
+                                      </ns0:to>
+                                    </ns0:set>
+                                    <ns0:animEffect transition="in" filter="fade">
+                                      <ns0:cBhvr>
+                                        <ns0:cTn id="74" dur="500"/>
+                                        <ns0:tgtEl>
+                                          <ns0:spTgt spid="21"/>
+                                        </ns0:tgtEl>
+                                      </ns0:cBhvr>
+                                    </ns0:animEffect>
+                                    <ns0:anim calcmode="lin" valueType="num">
+                                      <ns0:cBhvr additive="base">
+                                        <ns0:cTn id="75" dur="500" fill="hold"/>
                                         <ns0:tgtEl>
                                           <ns0:spTgt spid="21"/>
                                         </ns0:tgtEl>
@@ -5556,6 +5653,7 @@
       <ns0:bldP spid="20" grpId="0"/>
       <ns0:bldP spid="21" grpId="0"/>
       <ns0:bldP spid="22" grpId="0"/>
+      <ns0:bldP spid="25" grpId="0"/>
     </ns0:bldLst>
   </ns0:timing>
 </ns0:sld>

</xml_diff>

<commit_message>
Rollback PPTX về bản d17800e theo yêu cầu (PowerPoint báo repair ở bản mới nhất)
</commit_message>
<xml_diff>
--- a/CareTouch-deck.pptx
+++ b/CareTouch-deck.pptx
@@ -4509,45 +4509,6 @@
           </a:p>
         </ns0:txBody>
       </ns0:sp>
-      <ns0:sp>
-        <ns0:nvSpPr>
-          <ns0:cNvPr id="26" name="Text 22"/>
-          <ns0:cNvSpPr/>
-          <ns0:nvPr/>
-        </ns0:nvSpPr>
-        <ns0:spPr>
-          <a:xfrm>
-            <a:off x="1188720" y="3465576"/>
-            <a:ext cx="1143000" cy="182880"/>
-          </a:xfrm>
-          <a:prstGeom prst="rect">
-            <a:avLst/>
-          </a:prstGeom>
-          <a:noFill/>
-          <a:ln/>
-        </ns0:spPr>
-        <ns0:txBody>
-          <a:bodyPr wrap="square" lIns="0" tIns="0" rIns="0" bIns="0" rtlCol="0" anchor="ctr"/>
-          <a:lstStyle/>
-          <a:p>
-            <a:pPr indent="0" marL="0">
-              <a:buNone/>
-            </a:pPr>
-            <a:r>
-              <a:rPr lang="en-US" sz="1000" dirty="0">
-                <a:solidFill>
-                  <a:srgbClr val="16302B"/>
-                </a:solidFill>
-                <a:latin typeface="Segoe UI" pitchFamily="34" charset="0"/>
-                <a:ea typeface="Segoe UI" pitchFamily="34" charset="-122"/>
-                <a:cs typeface="Segoe UI" pitchFamily="34" charset="-120"/>
-              </a:rPr>
-              <a:t>48 tr./tháng</a:t>
-            </a:r>
-            <a:endParaRPr lang="en-US" sz="1000" dirty="0"/>
-          </a:p>
-        </ns0:txBody>
-      </ns0:sp>
     </ns0:spTree>
   </ns0:cSld>
   <ns0:clrMapOvr>
@@ -4571,7 +4532,7 @@
         <ns0:cTn id="1" dur="indefinite" restart="never" nodeType="tmRoot">
           <ns0:childTnLst>
             <ns0:seq concurrent="1" nextAc="seek">
-              <ns0:cTn id="76" dur="indefinite" nodeType="mainSeq">
+              <ns0:cTn id="72" dur="indefinite" nodeType="mainSeq">
                 <ns0:childTnLst>
                   <ns0:par>
                     <ns0:cTn id="2" fill="hold">
@@ -4759,21 +4720,39 @@
                                   </ns0:childTnLst>
                                 </ns0:cTn>
                               </ns0:par>
+                            </ns0:childTnLst>
+                          </ns0:cTn>
+                        </ns0:par>
+                      </ns0:childTnLst>
+                    </ns0:cTn>
+                  </ns0:par>
+                  <ns0:par>
+                    <ns0:cTn id="16" fill="hold">
+                      <ns0:stCondLst>
+                        <ns0:cond delay="indefinite"/>
+                      </ns0:stCondLst>
+                      <ns0:childTnLst>
+                        <ns0:par>
+                          <ns0:cTn id="17" fill="hold">
+                            <ns0:stCondLst>
+                              <ns0:cond delay="0"/>
+                            </ns0:stCondLst>
+                            <ns0:childTnLst>
                               <ns0:par>
-                                <ns0:cTn id="16" presetID="42" presetClass="entr" presetSubtype="0" fill="hold" grpId="0" nodeType="withEffect">
+                                <ns0:cTn id="18" presetID="42" presetClass="entr" presetSubtype="0" fill="hold" grpId="0" nodeType="clickEffect">
                                   <ns0:stCondLst>
-                                    <ns0:cond delay="300"/>
+                                    <ns0:cond delay="0"/>
                                   </ns0:stCondLst>
                                   <ns0:childTnLst>
                                     <ns0:set>
                                       <ns0:cBhvr>
-                                        <ns0:cTn id="17" dur="1" fill="hold">
+                                        <ns0:cTn id="19" dur="1" fill="hold">
                                           <ns0:stCondLst>
                                             <ns0:cond delay="0"/>
                                           </ns0:stCondLst>
                                         </ns0:cTn>
                                         <ns0:tgtEl>
-                                          <ns0:spTgt spid="25"/>
+                                          <ns0:spTgt spid="22"/>
                                         </ns0:tgtEl>
                                         <ns0:attrNameLst>
                                           <ns0:attrName>style.visibility</ns0:attrName>
@@ -4785,17 +4764,17 @@
                                     </ns0:set>
                                     <ns0:animEffect transition="in" filter="fade">
                                       <ns0:cBhvr>
-                                        <ns0:cTn id="18" dur="500"/>
-                                        <ns0:tgtEl>
-                                          <ns0:spTgt spid="25"/>
+                                        <ns0:cTn id="20" dur="500"/>
+                                        <ns0:tgtEl>
+                                          <ns0:spTgt spid="22"/>
                                         </ns0:tgtEl>
                                       </ns0:cBhvr>
                                     </ns0:animEffect>
                                     <ns0:anim calcmode="lin" valueType="num">
                                       <ns0:cBhvr additive="base">
-                                        <ns0:cTn id="19" dur="500" fill="hold"/>
-                                        <ns0:tgtEl>
-                                          <ns0:spTgt spid="25"/>
+                                        <ns0:cTn id="21" dur="500" fill="hold"/>
+                                        <ns0:tgtEl>
+                                          <ns0:spTgt spid="22"/>
                                         </ns0:tgtEl>
                                         <ns0:attrNameLst>
                                           <ns0:attrName>ppt_y</ns0:attrName>
@@ -4824,32 +4803,32 @@
                     </ns0:cTn>
                   </ns0:par>
                   <ns0:par>
-                    <ns0:cTn id="20" fill="hold">
+                    <ns0:cTn id="22" fill="hold">
                       <ns0:stCondLst>
                         <ns0:cond delay="indefinite"/>
                       </ns0:stCondLst>
                       <ns0:childTnLst>
                         <ns0:par>
-                          <ns0:cTn id="21" fill="hold">
+                          <ns0:cTn id="23" fill="hold">
                             <ns0:stCondLst>
                               <ns0:cond delay="0"/>
                             </ns0:stCondLst>
                             <ns0:childTnLst>
                               <ns0:par>
-                                <ns0:cTn id="22" presetID="42" presetClass="entr" presetSubtype="0" fill="hold" grpId="0" nodeType="clickEffect">
+                                <ns0:cTn id="24" presetID="42" presetClass="entr" presetSubtype="0" fill="hold" grpId="0" nodeType="clickEffect">
                                   <ns0:stCondLst>
                                     <ns0:cond delay="0"/>
                                   </ns0:stCondLst>
                                   <ns0:childTnLst>
                                     <ns0:set>
                                       <ns0:cBhvr>
-                                        <ns0:cTn id="23" dur="1" fill="hold">
+                                        <ns0:cTn id="25" dur="1" fill="hold">
                                           <ns0:stCondLst>
                                             <ns0:cond delay="0"/>
                                           </ns0:stCondLst>
                                         </ns0:cTn>
                                         <ns0:tgtEl>
-                                          <ns0:spTgt spid="22"/>
+                                          <ns0:spTgt spid="10"/>
                                         </ns0:tgtEl>
                                         <ns0:attrNameLst>
                                           <ns0:attrName>style.visibility</ns0:attrName>
@@ -4861,17 +4840,17 @@
                                     </ns0:set>
                                     <ns0:animEffect transition="in" filter="fade">
                                       <ns0:cBhvr>
-                                        <ns0:cTn id="24" dur="500"/>
-                                        <ns0:tgtEl>
-                                          <ns0:spTgt spid="22"/>
+                                        <ns0:cTn id="26" dur="500"/>
+                                        <ns0:tgtEl>
+                                          <ns0:spTgt spid="10"/>
                                         </ns0:tgtEl>
                                       </ns0:cBhvr>
                                     </ns0:animEffect>
                                     <ns0:anim calcmode="lin" valueType="num">
                                       <ns0:cBhvr additive="base">
-                                        <ns0:cTn id="25" dur="500" fill="hold"/>
-                                        <ns0:tgtEl>
-                                          <ns0:spTgt spid="22"/>
+                                        <ns0:cTn id="27" dur="500" fill="hold"/>
+                                        <ns0:tgtEl>
+                                          <ns0:spTgt spid="10"/>
                                         </ns0:tgtEl>
                                         <ns0:attrNameLst>
                                           <ns0:attrName>ppt_y</ns0:attrName>
@@ -4893,28 +4872,10 @@
                                   </ns0:childTnLst>
                                 </ns0:cTn>
                               </ns0:par>
-                            </ns0:childTnLst>
-                          </ns0:cTn>
-                        </ns0:par>
-                      </ns0:childTnLst>
-                    </ns0:cTn>
-                  </ns0:par>
-                  <ns0:par>
-                    <ns0:cTn id="26" fill="hold">
-                      <ns0:stCondLst>
-                        <ns0:cond delay="indefinite"/>
-                      </ns0:stCondLst>
-                      <ns0:childTnLst>
-                        <ns0:par>
-                          <ns0:cTn id="27" fill="hold">
-                            <ns0:stCondLst>
-                              <ns0:cond delay="0"/>
-                            </ns0:stCondLst>
-                            <ns0:childTnLst>
                               <ns0:par>
-                                <ns0:cTn id="28" presetID="42" presetClass="entr" presetSubtype="0" fill="hold" grpId="0" nodeType="clickEffect">
+                                <ns0:cTn id="28" presetID="42" presetClass="entr" presetSubtype="0" fill="hold" grpId="0" nodeType="withEffect">
                                   <ns0:stCondLst>
-                                    <ns0:cond delay="0"/>
+                                    <ns0:cond delay="80"/>
                                   </ns0:stCondLst>
                                   <ns0:childTnLst>
                                     <ns0:set>
@@ -4925,7 +4886,7 @@
                                           </ns0:stCondLst>
                                         </ns0:cTn>
                                         <ns0:tgtEl>
-                                          <ns0:spTgt spid="10"/>
+                                          <ns0:spTgt spid="11"/>
                                         </ns0:tgtEl>
                                         <ns0:attrNameLst>
                                           <ns0:attrName>style.visibility</ns0:attrName>
@@ -4939,7 +4900,7 @@
                                       <ns0:cBhvr>
                                         <ns0:cTn id="30" dur="500"/>
                                         <ns0:tgtEl>
-                                          <ns0:spTgt spid="10"/>
+                                          <ns0:spTgt spid="11"/>
                                         </ns0:tgtEl>
                                       </ns0:cBhvr>
                                     </ns0:animEffect>
@@ -4947,7 +4908,7 @@
                                       <ns0:cBhvr additive="base">
                                         <ns0:cTn id="31" dur="500" fill="hold"/>
                                         <ns0:tgtEl>
-                                          <ns0:spTgt spid="10"/>
+                                          <ns0:spTgt spid="11"/>
                                         </ns0:tgtEl>
                                         <ns0:attrNameLst>
                                           <ns0:attrName>ppt_y</ns0:attrName>
@@ -4972,7 +4933,7 @@
                               <ns0:par>
                                 <ns0:cTn id="32" presetID="42" presetClass="entr" presetSubtype="0" fill="hold" grpId="0" nodeType="withEffect">
                                   <ns0:stCondLst>
-                                    <ns0:cond delay="80"/>
+                                    <ns0:cond delay="160"/>
                                   </ns0:stCondLst>
                                   <ns0:childTnLst>
                                     <ns0:set>
@@ -4983,7 +4944,7 @@
                                           </ns0:stCondLst>
                                         </ns0:cTn>
                                         <ns0:tgtEl>
-                                          <ns0:spTgt spid="11"/>
+                                          <ns0:spTgt spid="12"/>
                                         </ns0:tgtEl>
                                         <ns0:attrNameLst>
                                           <ns0:attrName>style.visibility</ns0:attrName>
@@ -4997,7 +4958,7 @@
                                       <ns0:cBhvr>
                                         <ns0:cTn id="34" dur="500"/>
                                         <ns0:tgtEl>
-                                          <ns0:spTgt spid="11"/>
+                                          <ns0:spTgt spid="12"/>
                                         </ns0:tgtEl>
                                       </ns0:cBhvr>
                                     </ns0:animEffect>
@@ -5005,7 +4966,7 @@
                                       <ns0:cBhvr additive="base">
                                         <ns0:cTn id="35" dur="500" fill="hold"/>
                                         <ns0:tgtEl>
-                                          <ns0:spTgt spid="11"/>
+                                          <ns0:spTgt spid="12"/>
                                         </ns0:tgtEl>
                                         <ns0:attrNameLst>
                                           <ns0:attrName>ppt_y</ns0:attrName>
@@ -5030,7 +4991,7 @@
                               <ns0:par>
                                 <ns0:cTn id="36" presetID="42" presetClass="entr" presetSubtype="0" fill="hold" grpId="0" nodeType="withEffect">
                                   <ns0:stCondLst>
-                                    <ns0:cond delay="160"/>
+                                    <ns0:cond delay="240"/>
                                   </ns0:stCondLst>
                                   <ns0:childTnLst>
                                     <ns0:set>
@@ -5041,7 +5002,7 @@
                                           </ns0:stCondLst>
                                         </ns0:cTn>
                                         <ns0:tgtEl>
-                                          <ns0:spTgt spid="12"/>
+                                          <ns0:spTgt spid="13"/>
                                         </ns0:tgtEl>
                                         <ns0:attrNameLst>
                                           <ns0:attrName>style.visibility</ns0:attrName>
@@ -5055,7 +5016,7 @@
                                       <ns0:cBhvr>
                                         <ns0:cTn id="38" dur="500"/>
                                         <ns0:tgtEl>
-                                          <ns0:spTgt spid="12"/>
+                                          <ns0:spTgt spid="13"/>
                                         </ns0:tgtEl>
                                       </ns0:cBhvr>
                                     </ns0:animEffect>
@@ -5063,7 +5024,7 @@
                                       <ns0:cBhvr additive="base">
                                         <ns0:cTn id="39" dur="500" fill="hold"/>
                                         <ns0:tgtEl>
-                                          <ns0:spTgt spid="12"/>
+                                          <ns0:spTgt spid="13"/>
                                         </ns0:tgtEl>
                                         <ns0:attrNameLst>
                                           <ns0:attrName>ppt_y</ns0:attrName>
@@ -5088,7 +5049,7 @@
                               <ns0:par>
                                 <ns0:cTn id="40" presetID="42" presetClass="entr" presetSubtype="0" fill="hold" grpId="0" nodeType="withEffect">
                                   <ns0:stCondLst>
-                                    <ns0:cond delay="240"/>
+                                    <ns0:cond delay="320"/>
                                   </ns0:stCondLst>
                                   <ns0:childTnLst>
                                     <ns0:set>
@@ -5099,7 +5060,7 @@
                                           </ns0:stCondLst>
                                         </ns0:cTn>
                                         <ns0:tgtEl>
-                                          <ns0:spTgt spid="13"/>
+                                          <ns0:spTgt spid="14"/>
                                         </ns0:tgtEl>
                                         <ns0:attrNameLst>
                                           <ns0:attrName>style.visibility</ns0:attrName>
@@ -5113,7 +5074,7 @@
                                       <ns0:cBhvr>
                                         <ns0:cTn id="42" dur="500"/>
                                         <ns0:tgtEl>
-                                          <ns0:spTgt spid="13"/>
+                                          <ns0:spTgt spid="14"/>
                                         </ns0:tgtEl>
                                       </ns0:cBhvr>
                                     </ns0:animEffect>
@@ -5121,7 +5082,7 @@
                                       <ns0:cBhvr additive="base">
                                         <ns0:cTn id="43" dur="500" fill="hold"/>
                                         <ns0:tgtEl>
-                                          <ns0:spTgt spid="13"/>
+                                          <ns0:spTgt spid="14"/>
                                         </ns0:tgtEl>
                                         <ns0:attrNameLst>
                                           <ns0:attrName>ppt_y</ns0:attrName>
@@ -5146,7 +5107,7 @@
                               <ns0:par>
                                 <ns0:cTn id="44" presetID="42" presetClass="entr" presetSubtype="0" fill="hold" grpId="0" nodeType="withEffect">
                                   <ns0:stCondLst>
-                                    <ns0:cond delay="320"/>
+                                    <ns0:cond delay="400"/>
                                   </ns0:stCondLst>
                                   <ns0:childTnLst>
                                     <ns0:set>
@@ -5157,7 +5118,7 @@
                                           </ns0:stCondLst>
                                         </ns0:cTn>
                                         <ns0:tgtEl>
-                                          <ns0:spTgt spid="14"/>
+                                          <ns0:spTgt spid="15"/>
                                         </ns0:tgtEl>
                                         <ns0:attrNameLst>
                                           <ns0:attrName>style.visibility</ns0:attrName>
@@ -5171,7 +5132,7 @@
                                       <ns0:cBhvr>
                                         <ns0:cTn id="46" dur="500"/>
                                         <ns0:tgtEl>
-                                          <ns0:spTgt spid="14"/>
+                                          <ns0:spTgt spid="15"/>
                                         </ns0:tgtEl>
                                       </ns0:cBhvr>
                                     </ns0:animEffect>
@@ -5179,7 +5140,7 @@
                                       <ns0:cBhvr additive="base">
                                         <ns0:cTn id="47" dur="500" fill="hold"/>
                                         <ns0:tgtEl>
-                                          <ns0:spTgt spid="14"/>
+                                          <ns0:spTgt spid="15"/>
                                         </ns0:tgtEl>
                                         <ns0:attrNameLst>
                                           <ns0:attrName>ppt_y</ns0:attrName>
@@ -5204,7 +5165,7 @@
                               <ns0:par>
                                 <ns0:cTn id="48" presetID="42" presetClass="entr" presetSubtype="0" fill="hold" grpId="0" nodeType="withEffect">
                                   <ns0:stCondLst>
-                                    <ns0:cond delay="400"/>
+                                    <ns0:cond delay="480"/>
                                   </ns0:stCondLst>
                                   <ns0:childTnLst>
                                     <ns0:set>
@@ -5215,7 +5176,7 @@
                                           </ns0:stCondLst>
                                         </ns0:cTn>
                                         <ns0:tgtEl>
-                                          <ns0:spTgt spid="15"/>
+                                          <ns0:spTgt spid="16"/>
                                         </ns0:tgtEl>
                                         <ns0:attrNameLst>
                                           <ns0:attrName>style.visibility</ns0:attrName>
@@ -5229,7 +5190,7 @@
                                       <ns0:cBhvr>
                                         <ns0:cTn id="50" dur="500"/>
                                         <ns0:tgtEl>
-                                          <ns0:spTgt spid="15"/>
+                                          <ns0:spTgt spid="16"/>
                                         </ns0:tgtEl>
                                       </ns0:cBhvr>
                                     </ns0:animEffect>
@@ -5237,7 +5198,7 @@
                                       <ns0:cBhvr additive="base">
                                         <ns0:cTn id="51" dur="500" fill="hold"/>
                                         <ns0:tgtEl>
-                                          <ns0:spTgt spid="15"/>
+                                          <ns0:spTgt spid="16"/>
                                         </ns0:tgtEl>
                                         <ns0:attrNameLst>
                                           <ns0:attrName>ppt_y</ns0:attrName>
@@ -5262,7 +5223,7 @@
                               <ns0:par>
                                 <ns0:cTn id="52" presetID="42" presetClass="entr" presetSubtype="0" fill="hold" grpId="0" nodeType="withEffect">
                                   <ns0:stCondLst>
-                                    <ns0:cond delay="480"/>
+                                    <ns0:cond delay="560"/>
                                   </ns0:stCondLst>
                                   <ns0:childTnLst>
                                     <ns0:set>
@@ -5273,7 +5234,7 @@
                                           </ns0:stCondLst>
                                         </ns0:cTn>
                                         <ns0:tgtEl>
-                                          <ns0:spTgt spid="16"/>
+                                          <ns0:spTgt spid="17"/>
                                         </ns0:tgtEl>
                                         <ns0:attrNameLst>
                                           <ns0:attrName>style.visibility</ns0:attrName>
@@ -5287,7 +5248,7 @@
                                       <ns0:cBhvr>
                                         <ns0:cTn id="54" dur="500"/>
                                         <ns0:tgtEl>
-                                          <ns0:spTgt spid="16"/>
+                                          <ns0:spTgt spid="17"/>
                                         </ns0:tgtEl>
                                       </ns0:cBhvr>
                                     </ns0:animEffect>
@@ -5295,7 +5256,7 @@
                                       <ns0:cBhvr additive="base">
                                         <ns0:cTn id="55" dur="500" fill="hold"/>
                                         <ns0:tgtEl>
-                                          <ns0:spTgt spid="16"/>
+                                          <ns0:spTgt spid="17"/>
                                         </ns0:tgtEl>
                                         <ns0:attrNameLst>
                                           <ns0:attrName>ppt_y</ns0:attrName>
@@ -5320,7 +5281,7 @@
                               <ns0:par>
                                 <ns0:cTn id="56" presetID="42" presetClass="entr" presetSubtype="0" fill="hold" grpId="0" nodeType="withEffect">
                                   <ns0:stCondLst>
-                                    <ns0:cond delay="560"/>
+                                    <ns0:cond delay="640"/>
                                   </ns0:stCondLst>
                                   <ns0:childTnLst>
                                     <ns0:set>
@@ -5331,7 +5292,7 @@
                                           </ns0:stCondLst>
                                         </ns0:cTn>
                                         <ns0:tgtEl>
-                                          <ns0:spTgt spid="17"/>
+                                          <ns0:spTgt spid="18"/>
                                         </ns0:tgtEl>
                                         <ns0:attrNameLst>
                                           <ns0:attrName>style.visibility</ns0:attrName>
@@ -5345,7 +5306,7 @@
                                       <ns0:cBhvr>
                                         <ns0:cTn id="58" dur="500"/>
                                         <ns0:tgtEl>
-                                          <ns0:spTgt spid="17"/>
+                                          <ns0:spTgt spid="18"/>
                                         </ns0:tgtEl>
                                       </ns0:cBhvr>
                                     </ns0:animEffect>
@@ -5353,7 +5314,7 @@
                                       <ns0:cBhvr additive="base">
                                         <ns0:cTn id="59" dur="500" fill="hold"/>
                                         <ns0:tgtEl>
-                                          <ns0:spTgt spid="17"/>
+                                          <ns0:spTgt spid="18"/>
                                         </ns0:tgtEl>
                                         <ns0:attrNameLst>
                                           <ns0:attrName>ppt_y</ns0:attrName>
@@ -5378,7 +5339,7 @@
                               <ns0:par>
                                 <ns0:cTn id="60" presetID="42" presetClass="entr" presetSubtype="0" fill="hold" grpId="0" nodeType="withEffect">
                                   <ns0:stCondLst>
-                                    <ns0:cond delay="640"/>
+                                    <ns0:cond delay="720"/>
                                   </ns0:stCondLst>
                                   <ns0:childTnLst>
                                     <ns0:set>
@@ -5389,7 +5350,7 @@
                                           </ns0:stCondLst>
                                         </ns0:cTn>
                                         <ns0:tgtEl>
-                                          <ns0:spTgt spid="18"/>
+                                          <ns0:spTgt spid="19"/>
                                         </ns0:tgtEl>
                                         <ns0:attrNameLst>
                                           <ns0:attrName>style.visibility</ns0:attrName>
@@ -5403,7 +5364,7 @@
                                       <ns0:cBhvr>
                                         <ns0:cTn id="62" dur="500"/>
                                         <ns0:tgtEl>
-                                          <ns0:spTgt spid="18"/>
+                                          <ns0:spTgt spid="19"/>
                                         </ns0:tgtEl>
                                       </ns0:cBhvr>
                                     </ns0:animEffect>
@@ -5411,7 +5372,7 @@
                                       <ns0:cBhvr additive="base">
                                         <ns0:cTn id="63" dur="500" fill="hold"/>
                                         <ns0:tgtEl>
-                                          <ns0:spTgt spid="18"/>
+                                          <ns0:spTgt spid="19"/>
                                         </ns0:tgtEl>
                                         <ns0:attrNameLst>
                                           <ns0:attrName>ppt_y</ns0:attrName>
@@ -5436,7 +5397,7 @@
                               <ns0:par>
                                 <ns0:cTn id="64" presetID="42" presetClass="entr" presetSubtype="0" fill="hold" grpId="0" nodeType="withEffect">
                                   <ns0:stCondLst>
-                                    <ns0:cond delay="720"/>
+                                    <ns0:cond delay="800"/>
                                   </ns0:stCondLst>
                                   <ns0:childTnLst>
                                     <ns0:set>
@@ -5447,7 +5408,7 @@
                                           </ns0:stCondLst>
                                         </ns0:cTn>
                                         <ns0:tgtEl>
-                                          <ns0:spTgt spid="19"/>
+                                          <ns0:spTgt spid="20"/>
                                         </ns0:tgtEl>
                                         <ns0:attrNameLst>
                                           <ns0:attrName>style.visibility</ns0:attrName>
@@ -5461,7 +5422,7 @@
                                       <ns0:cBhvr>
                                         <ns0:cTn id="66" dur="500"/>
                                         <ns0:tgtEl>
-                                          <ns0:spTgt spid="19"/>
+                                          <ns0:spTgt spid="20"/>
                                         </ns0:tgtEl>
                                       </ns0:cBhvr>
                                     </ns0:animEffect>
@@ -5469,7 +5430,7 @@
                                       <ns0:cBhvr additive="base">
                                         <ns0:cTn id="67" dur="500" fill="hold"/>
                                         <ns0:tgtEl>
-                                          <ns0:spTgt spid="19"/>
+                                          <ns0:spTgt spid="20"/>
                                         </ns0:tgtEl>
                                         <ns0:attrNameLst>
                                           <ns0:attrName>ppt_y</ns0:attrName>
@@ -5494,7 +5455,7 @@
                               <ns0:par>
                                 <ns0:cTn id="68" presetID="42" presetClass="entr" presetSubtype="0" fill="hold" grpId="0" nodeType="withEffect">
                                   <ns0:stCondLst>
-                                    <ns0:cond delay="800"/>
+                                    <ns0:cond delay="880"/>
                                   </ns0:stCondLst>
                                   <ns0:childTnLst>
                                     <ns0:set>
@@ -5505,7 +5466,7 @@
                                           </ns0:stCondLst>
                                         </ns0:cTn>
                                         <ns0:tgtEl>
-                                          <ns0:spTgt spid="20"/>
+                                          <ns0:spTgt spid="21"/>
                                         </ns0:tgtEl>
                                         <ns0:attrNameLst>
                                           <ns0:attrName>style.visibility</ns0:attrName>
@@ -5519,71 +5480,13 @@
                                       <ns0:cBhvr>
                                         <ns0:cTn id="70" dur="500"/>
                                         <ns0:tgtEl>
-                                          <ns0:spTgt spid="20"/>
+                                          <ns0:spTgt spid="21"/>
                                         </ns0:tgtEl>
                                       </ns0:cBhvr>
                                     </ns0:animEffect>
                                     <ns0:anim calcmode="lin" valueType="num">
                                       <ns0:cBhvr additive="base">
                                         <ns0:cTn id="71" dur="500" fill="hold"/>
-                                        <ns0:tgtEl>
-                                          <ns0:spTgt spid="20"/>
-                                        </ns0:tgtEl>
-                                        <ns0:attrNameLst>
-                                          <ns0:attrName>ppt_y</ns0:attrName>
-                                        </ns0:attrNameLst>
-                                      </ns0:cBhvr>
-                                      <ns0:tavLst>
-                                        <ns0:tav tm="0">
-                                          <ns0:val>
-                                            <ns0:strVal val="#ppt_y+0.018"/>
-                                          </ns0:val>
-                                        </ns0:tav>
-                                        <ns0:tav tm="100000">
-                                          <ns0:val>
-                                            <ns0:strVal val="#ppt_y"/>
-                                          </ns0:val>
-                                        </ns0:tav>
-                                      </ns0:tavLst>
-                                    </ns0:anim>
-                                  </ns0:childTnLst>
-                                </ns0:cTn>
-                              </ns0:par>
-                              <ns0:par>
-                                <ns0:cTn id="72" presetID="42" presetClass="entr" presetSubtype="0" fill="hold" grpId="0" nodeType="withEffect">
-                                  <ns0:stCondLst>
-                                    <ns0:cond delay="880"/>
-                                  </ns0:stCondLst>
-                                  <ns0:childTnLst>
-                                    <ns0:set>
-                                      <ns0:cBhvr>
-                                        <ns0:cTn id="73" dur="1" fill="hold">
-                                          <ns0:stCondLst>
-                                            <ns0:cond delay="0"/>
-                                          </ns0:stCondLst>
-                                        </ns0:cTn>
-                                        <ns0:tgtEl>
-                                          <ns0:spTgt spid="21"/>
-                                        </ns0:tgtEl>
-                                        <ns0:attrNameLst>
-                                          <ns0:attrName>style.visibility</ns0:attrName>
-                                        </ns0:attrNameLst>
-                                      </ns0:cBhvr>
-                                      <ns0:to>
-                                        <ns0:strVal val="visible"/>
-                                      </ns0:to>
-                                    </ns0:set>
-                                    <ns0:animEffect transition="in" filter="fade">
-                                      <ns0:cBhvr>
-                                        <ns0:cTn id="74" dur="500"/>
-                                        <ns0:tgtEl>
-                                          <ns0:spTgt spid="21"/>
-                                        </ns0:tgtEl>
-                                      </ns0:cBhvr>
-                                    </ns0:animEffect>
-                                    <ns0:anim calcmode="lin" valueType="num">
-                                      <ns0:cBhvr additive="base">
-                                        <ns0:cTn id="75" dur="500" fill="hold"/>
                                         <ns0:tgtEl>
                                           <ns0:spTgt spid="21"/>
                                         </ns0:tgtEl>
@@ -5653,7 +5556,6 @@
       <ns0:bldP spid="20" grpId="0"/>
       <ns0:bldP spid="21" grpId="0"/>
       <ns0:bldP spid="22" grpId="0"/>
-      <ns0:bldP spid="25" grpId="0"/>
     </ns0:bldLst>
   </ns0:timing>
 </ns0:sld>

</xml_diff>